<commit_message>
Expand rewards into a points-based milestone ladder + grand prize
Redesign the rewards mechanism as escalating checkpoints unlocked by
points balance: 150 (certificate + badge), 350 (former national-team
player visit), 650 (current national-team player visit + training
session), 1000 (workshop with the national-team coach). Add a dedicated
Grand Prize slide at 1500 points: an official letter of appreciation from
the Ministers of Education and Sport addressed to the school and its PE
teacher, plus support to obtain a coaching license free of charge. Deck
grows from 9 to 10 slides.

Co-Authored-By: Claude Opus 4.8 <noreply@anthropic.com>
Claude-Session: https://claude.ai/code/session_01CRtFGBa3Bgrckq7s7erfp6
</commit_message>
<xml_diff>
--- a/SAFF-Gamification-Schools-League.pptx
+++ b/SAFF-Gamification-Schools-League.pptx
@@ -17,6 +17,7 @@
     <p:sldId id="262" r:id="rId16"/>
     <p:sldId id="263" r:id="rId17"/>
     <p:sldId id="264" r:id="rId18"/>
+    <p:sldId id="265" r:id="rId19"/>
   </p:sldIdLst>
   <p:sldSz cx="12192000" cy="6858000" type="screen16x9"/>
   <p:notesSz cx="6858000" cy="9144000"/>
@@ -91,6 +92,51 @@
 </p:notes>
 </file>
 
+<file path=ppt/notesSlides/notesSlide10.xml><?xml version="1.0" encoding="utf-8"?>
+<p:notes xmlns:a="http://schemas.openxmlformats.org/drawingml/2006/main" xmlns:r="http://schemas.openxmlformats.org/officeDocument/2006/relationships" xmlns:p="http://schemas.openxmlformats.org/presentationml/2006/main">
+  <p:cSld>
+    <p:spTree>
+      <p:nvGrpSpPr>
+        <p:cNvPr id="1" name=""/>
+        <p:cNvGrpSpPr/>
+        <p:nvPr/>
+      </p:nvGrpSpPr>
+      <p:grpSpPr>
+        <a:xfrm>
+          <a:off x="0" y="0"/>
+          <a:ext cx="0" cy="0"/>
+          <a:chOff x="0" y="0"/>
+          <a:chExt cx="0" cy="0"/>
+        </a:xfrm>
+      </p:grpSpPr>
+      <p:sp>
+        <p:nvSpPr>
+          <p:cNvPr id="2" name="Notes"/>
+          <p:cNvSpPr txBox="1"/>
+          <p:nvPr>
+            <p:ph type="body" idx="1"/>
+          </p:nvPr>
+        </p:nvSpPr>
+        <p:spPr/>
+        <p:txBody>
+          <a:bodyPr/>
+          <a:lstStyle/>
+          <a:p>
+            <a:r>
+              <a:rPr lang="ar-SA"/>
+              <a:t/>
+            </a:r>
+          </a:p>
+        </p:txBody>
+      </p:sp>
+    </p:spTree>
+  </p:cSld>
+  <p:clrMapOvr>
+    <a:masterClrMapping/>
+  </p:clrMapOvr>
+</p:notes>
+</file>
+
 <file path=ppt/notesSlides/notesSlide2.xml><?xml version="1.0" encoding="utf-8"?>
 <p:notes xmlns:a="http://schemas.openxmlformats.org/drawingml/2006/main" xmlns:r="http://schemas.openxmlformats.org/officeDocument/2006/relationships" xmlns:p="http://schemas.openxmlformats.org/presentationml/2006/main">
   <p:cSld>
@@ -393,7 +439,7 @@
           <a:p>
             <a:r>
               <a:rPr lang="ar-SA"/>
-              <a:t/>
+              <a:t>محطات مبنية على رصيد النقاط: 150 شهادة وشارة، 350 زيارة لاعب سابق، 650 زيارة لاعب من المنتخب الحالي مع حصة، 1000 لقاء مع مدرب المنتخب، ثم الجائزة الكبرى.</a:t>
             </a:r>
           </a:p>
         </p:txBody>
@@ -438,7 +484,7 @@
           <a:p>
             <a:r>
               <a:rPr lang="ar-SA"/>
-              <a:t/>
+              <a:t>الجائزة الكبرى عند 1500 نقطة: خطاب شكر وتقدير من وزير التعليم ووزير الرياضة باسم المدرسة ومعلم الرياضة، ودعم الحصول على رخصة تدريب مجانًا بدون رسوم.</a:t>
             </a:r>
           </a:p>
         </p:txBody>
@@ -784,6 +830,403 @@
 </p:sld>
 </file>
 
+<file path=ppt/slides/slide10.xml><?xml version="1.0" encoding="utf-8"?>
+<p:sld xmlns:a="http://schemas.openxmlformats.org/drawingml/2006/main" xmlns:r="http://schemas.openxmlformats.org/officeDocument/2006/relationships" xmlns:p="http://schemas.openxmlformats.org/presentationml/2006/main">
+  <p:cSld>
+    <p:spTree>
+      <p:nvGrpSpPr>
+        <p:cNvPr id="1" name=""/>
+        <p:cNvGrpSpPr/>
+        <p:nvPr/>
+      </p:nvGrpSpPr>
+      <p:grpSpPr>
+        <a:xfrm>
+          <a:off x="0" y="0"/>
+          <a:ext cx="0" cy="0"/>
+          <a:chOff x="0" y="0"/>
+          <a:chExt cx="0" cy="0"/>
+        </a:xfrm>
+      </p:grpSpPr>
+      <p:sp>
+        <p:nvSpPr>
+          <p:cNvPr id="2" name="s2"/>
+          <p:cNvSpPr/>
+          <p:nvPr/>
+        </p:nvSpPr>
+        <p:spPr>
+          <a:xfrm>
+            <a:off x="0" y="0"/>
+            <a:ext cx="12191695" cy="6858000"/>
+          </a:xfrm>
+          <a:prstGeom prst="rect">
+            <a:avLst/>
+          </a:prstGeom>
+          <a:solidFill>
+            <a:srgbClr val="0C3B2E"/>
+          </a:solidFill>
+        </p:spPr>
+        <p:txBody>
+          <a:bodyPr/>
+          <a:lstStyle/>
+          <a:p/>
+        </p:txBody>
+      </p:sp>
+      <p:sp>
+        <p:nvSpPr>
+          <p:cNvPr id="3" name="s3"/>
+          <p:cNvSpPr/>
+          <p:nvPr/>
+        </p:nvSpPr>
+        <p:spPr>
+          <a:xfrm>
+            <a:off x="-2377440" y="3291840"/>
+            <a:ext cx="5852160" cy="5852160"/>
+          </a:xfrm>
+          <a:prstGeom prst="ellipse">
+            <a:avLst/>
+          </a:prstGeom>
+          <a:solidFill>
+            <a:srgbClr val="0A3227"/>
+          </a:solidFill>
+        </p:spPr>
+        <p:txBody>
+          <a:bodyPr/>
+          <a:lstStyle/>
+          <a:p/>
+        </p:txBody>
+      </p:sp>
+      <p:sp>
+        <p:nvSpPr>
+          <p:cNvPr id="4" name="s4"/>
+          <p:cNvSpPr/>
+          <p:nvPr/>
+        </p:nvSpPr>
+        <p:spPr>
+          <a:xfrm>
+            <a:off x="8595360" y="-2377440"/>
+            <a:ext cx="5852160" cy="5852160"/>
+          </a:xfrm>
+          <a:prstGeom prst="ellipse">
+            <a:avLst/>
+          </a:prstGeom>
+          <a:solidFill>
+            <a:srgbClr val="0A3227"/>
+          </a:solidFill>
+        </p:spPr>
+        <p:txBody>
+          <a:bodyPr/>
+          <a:lstStyle/>
+          <a:p/>
+        </p:txBody>
+      </p:sp>
+      <p:sp>
+        <p:nvSpPr>
+          <p:cNvPr id="5" name="s5"/>
+          <p:cNvSpPr/>
+          <p:nvPr/>
+        </p:nvSpPr>
+        <p:spPr>
+          <a:xfrm>
+            <a:off x="5458968" y="1051560"/>
+            <a:ext cx="1280160" cy="1280160"/>
+          </a:xfrm>
+          <a:prstGeom prst="ellipse">
+            <a:avLst/>
+          </a:prstGeom>
+          <a:solidFill>
+            <a:srgbClr val="E4A11B"/>
+          </a:solidFill>
+        </p:spPr>
+        <p:txBody>
+          <a:bodyPr/>
+          <a:lstStyle/>
+          <a:p/>
+        </p:txBody>
+      </p:sp>
+      <p:sp>
+        <p:nvSpPr>
+          <p:cNvPr id="6" name="t6"/>
+          <p:cNvSpPr txBox="1"/>
+          <p:nvPr/>
+        </p:nvSpPr>
+        <p:spPr>
+          <a:xfrm>
+            <a:off x="5458968" y="1051560"/>
+            <a:ext cx="1280160" cy="1280160"/>
+          </a:xfrm>
+          <a:prstGeom prst="rect">
+            <a:avLst/>
+          </a:prstGeom>
+          <a:noFill/>
+        </p:spPr>
+        <p:txBody>
+          <a:bodyPr wrap="square" lIns="0" tIns="0" rIns="0" bIns="0" anchor="ctr" rtlCol="1">
+            <a:normAutofit/>
+          </a:bodyPr>
+          <a:lstStyle/>
+          <a:p>
+            <a:pPr algn="ctr" rtl="0"/>
+            <a:r>
+              <a:rPr lang="ar-SA" sz="4400" b="1" dirty="0">
+                <a:solidFill>
+                  <a:srgbClr val="0C3B2E"/>
+                </a:solidFill>
+                <a:latin typeface="Arial"/>
+                <a:cs typeface="Arial"/>
+              </a:rPr>
+              <a:t>★</a:t>
+            </a:r>
+          </a:p>
+        </p:txBody>
+      </p:sp>
+      <p:sp>
+        <p:nvSpPr>
+          <p:cNvPr id="7" name="t7"/>
+          <p:cNvSpPr txBox="1"/>
+          <p:nvPr/>
+        </p:nvSpPr>
+        <p:spPr>
+          <a:xfrm>
+            <a:off x="914400" y="2606040"/>
+            <a:ext cx="10360152" cy="914400"/>
+          </a:xfrm>
+          <a:prstGeom prst="rect">
+            <a:avLst/>
+          </a:prstGeom>
+          <a:noFill/>
+        </p:spPr>
+        <p:txBody>
+          <a:bodyPr wrap="square" lIns="54864" tIns="18288" rIns="54864" bIns="18288" anchor="t" rtlCol="1">
+            <a:normAutofit/>
+          </a:bodyPr>
+          <a:lstStyle/>
+          <a:p>
+            <a:pPr algn="ctr" rtl="1"/>
+            <a:r>
+              <a:rPr lang="ar-SA" sz="3000" b="1" dirty="0">
+                <a:solidFill>
+                  <a:srgbClr val="FFFFFF"/>
+                </a:solidFill>
+                <a:latin typeface="Arial"/>
+                <a:cs typeface="Arial"/>
+              </a:rPr>
+              <a:t>حركة أكثر، ومنافسة أمتع، وأثر مستدام</a:t>
+            </a:r>
+          </a:p>
+        </p:txBody>
+      </p:sp>
+      <p:sp>
+        <p:nvSpPr>
+          <p:cNvPr id="8" name="t8"/>
+          <p:cNvSpPr txBox="1"/>
+          <p:nvPr/>
+        </p:nvSpPr>
+        <p:spPr>
+          <a:xfrm>
+            <a:off x="1371600" y="3611880"/>
+            <a:ext cx="9445752" cy="822960"/>
+          </a:xfrm>
+          <a:prstGeom prst="rect">
+            <a:avLst/>
+          </a:prstGeom>
+          <a:noFill/>
+        </p:spPr>
+        <p:txBody>
+          <a:bodyPr wrap="square" lIns="54864" tIns="18288" rIns="54864" bIns="18288" anchor="t" rtlCol="1">
+            <a:normAutofit/>
+          </a:bodyPr>
+          <a:lstStyle/>
+          <a:p>
+            <a:pPr algn="ctr" rtl="1"/>
+            <a:r>
+              <a:rPr lang="ar-SA" sz="1600" dirty="0">
+                <a:solidFill>
+                  <a:srgbClr val="BFE3D0"/>
+                </a:solidFill>
+                <a:latin typeface="Arial"/>
+                <a:cs typeface="Arial"/>
+              </a:rPr>
+              <a:t>نظام تحفيز بسيط وعادل وقابل للقياس — يركّز النقاط على ما يصنع الفرق: المباريات والحصص التدريبية.</a:t>
+            </a:r>
+          </a:p>
+        </p:txBody>
+      </p:sp>
+      <p:sp>
+        <p:nvSpPr>
+          <p:cNvPr id="9" name="s9"/>
+          <p:cNvSpPr/>
+          <p:nvPr/>
+        </p:nvSpPr>
+        <p:spPr>
+          <a:xfrm>
+            <a:off x="3794760" y="4709160"/>
+            <a:ext cx="2103120" cy="1234440"/>
+          </a:xfrm>
+          <a:prstGeom prst="roundRect">
+            <a:avLst>
+              <a:gd name="adj" fmla="val 10000"/>
+            </a:avLst>
+          </a:prstGeom>
+          <a:solidFill>
+            <a:srgbClr val="0A3227"/>
+          </a:solidFill>
+          <a:ln w="15875">
+            <a:solidFill>
+              <a:srgbClr val="E4A11B"/>
+            </a:solidFill>
+          </a:ln>
+        </p:spPr>
+        <p:txBody>
+          <a:bodyPr/>
+          <a:lstStyle/>
+          <a:p/>
+        </p:txBody>
+      </p:sp>
+      <p:sp>
+        <p:nvSpPr>
+          <p:cNvPr id="10" name="t10"/>
+          <p:cNvSpPr txBox="1"/>
+          <p:nvPr/>
+        </p:nvSpPr>
+        <p:spPr>
+          <a:xfrm>
+            <a:off x="3794760" y="4800600"/>
+            <a:ext cx="2103120" cy="1097280"/>
+          </a:xfrm>
+          <a:prstGeom prst="rect">
+            <a:avLst/>
+          </a:prstGeom>
+          <a:noFill/>
+        </p:spPr>
+        <p:txBody>
+          <a:bodyPr wrap="square" lIns="54864" tIns="36576" rIns="54864" bIns="36576" anchor="ctr" rtlCol="1">
+            <a:normAutofit/>
+          </a:bodyPr>
+          <a:lstStyle/>
+          <a:p>
+            <a:pPr algn="ctr" rtl="0">
+              <a:spcAft>
+                <a:spcPts val="200"/>
+              </a:spcAft>
+            </a:pPr>
+            <a:r>
+              <a:rPr lang="ar-SA" sz="4000" b="1" dirty="0">
+                <a:solidFill>
+                  <a:srgbClr val="F4C542"/>
+                </a:solidFill>
+                <a:latin typeface="Arial"/>
+                <a:cs typeface="Arial"/>
+              </a:rPr>
+              <a:t>10</a:t>
+            </a:r>
+          </a:p>
+          <a:p>
+            <a:pPr algn="ctr" rtl="1"/>
+            <a:r>
+              <a:rPr lang="ar-SA" sz="1200" dirty="0">
+                <a:solidFill>
+                  <a:srgbClr val="FFFFFF"/>
+                </a:solidFill>
+                <a:latin typeface="Arial"/>
+                <a:cs typeface="Arial"/>
+              </a:rPr>
+              <a:t>نقاط / مباراة</a:t>
+            </a:r>
+          </a:p>
+        </p:txBody>
+      </p:sp>
+      <p:sp>
+        <p:nvSpPr>
+          <p:cNvPr id="11" name="s11"/>
+          <p:cNvSpPr/>
+          <p:nvPr/>
+        </p:nvSpPr>
+        <p:spPr>
+          <a:xfrm>
+            <a:off x="6291072" y="4709160"/>
+            <a:ext cx="2103120" cy="1234440"/>
+          </a:xfrm>
+          <a:prstGeom prst="roundRect">
+            <a:avLst>
+              <a:gd name="adj" fmla="val 10000"/>
+            </a:avLst>
+          </a:prstGeom>
+          <a:solidFill>
+            <a:srgbClr val="0A3227"/>
+          </a:solidFill>
+          <a:ln w="15875">
+            <a:solidFill>
+              <a:srgbClr val="E4A11B"/>
+            </a:solidFill>
+          </a:ln>
+        </p:spPr>
+        <p:txBody>
+          <a:bodyPr/>
+          <a:lstStyle/>
+          <a:p/>
+        </p:txBody>
+      </p:sp>
+      <p:sp>
+        <p:nvSpPr>
+          <p:cNvPr id="12" name="t12"/>
+          <p:cNvSpPr txBox="1"/>
+          <p:nvPr/>
+        </p:nvSpPr>
+        <p:spPr>
+          <a:xfrm>
+            <a:off x="6291072" y="4800600"/>
+            <a:ext cx="2103120" cy="1097280"/>
+          </a:xfrm>
+          <a:prstGeom prst="rect">
+            <a:avLst/>
+          </a:prstGeom>
+          <a:noFill/>
+        </p:spPr>
+        <p:txBody>
+          <a:bodyPr wrap="square" lIns="54864" tIns="36576" rIns="54864" bIns="36576" anchor="ctr" rtlCol="1">
+            <a:normAutofit/>
+          </a:bodyPr>
+          <a:lstStyle/>
+          <a:p>
+            <a:pPr algn="ctr" rtl="0">
+              <a:spcAft>
+                <a:spcPts val="200"/>
+              </a:spcAft>
+            </a:pPr>
+            <a:r>
+              <a:rPr lang="ar-SA" sz="4000" b="1" dirty="0">
+                <a:solidFill>
+                  <a:srgbClr val="F4C542"/>
+                </a:solidFill>
+                <a:latin typeface="Arial"/>
+                <a:cs typeface="Arial"/>
+              </a:rPr>
+              <a:t>15</a:t>
+            </a:r>
+          </a:p>
+          <a:p>
+            <a:pPr algn="ctr" rtl="1"/>
+            <a:r>
+              <a:rPr lang="ar-SA" sz="1200" dirty="0">
+                <a:solidFill>
+                  <a:srgbClr val="FFFFFF"/>
+                </a:solidFill>
+                <a:latin typeface="Arial"/>
+                <a:cs typeface="Arial"/>
+              </a:rPr>
+              <a:t>نقطة / حصة</a:t>
+            </a:r>
+          </a:p>
+        </p:txBody>
+      </p:sp>
+    </p:spTree>
+  </p:cSld>
+  <p:clrMapOvr>
+    <a:masterClrMapping/>
+  </p:clrMapOvr>
+</p:sld>
+</file>
+
 <file path=ppt/slides/slide2.xml><?xml version="1.0" encoding="utf-8"?>
 <p:sld xmlns:a="http://schemas.openxmlformats.org/drawingml/2006/main" xmlns:r="http://schemas.openxmlformats.org/officeDocument/2006/relationships" xmlns:p="http://schemas.openxmlformats.org/presentationml/2006/main">
   <p:cSld>
@@ -4282,7 +4725,7 @@
                 <a:latin typeface="Arial"/>
                 <a:cs typeface="Arial"/>
               </a:rPr>
-              <a:t>كيف تُصرف المكافآت والتكريم.</a:t>
+              <a:t>محطات نقاط تفتح مكافآت متتالية حتى الجائزة الكبرى.</a:t>
             </a:r>
           </a:p>
         </p:txBody>
@@ -5779,7 +6222,7 @@
                 <a:latin typeface="Arial"/>
                 <a:cs typeface="Arial"/>
               </a:rPr>
-              <a:t>تفصيل آلية الجوائز</a:t>
+              <a:t>آلية الجوائز — محطات النقاط</a:t>
             </a:r>
           </a:p>
         </p:txBody>
@@ -5815,7 +6258,7 @@
                 <a:latin typeface="Arial"/>
                 <a:cs typeface="Arial"/>
               </a:rPr>
-              <a:t>مستويات تحفيزية ومكافآت متدرّجة</a:t>
+              <a:t>كل محطة (Checkpoint) تُفتح تلقائيًا عند بلوغ رصيد النقاط، وتمنح المدرسة مكافأة</a:t>
             </a:r>
           </a:p>
         </p:txBody>
@@ -5828,16 +6271,16 @@
         </p:nvSpPr>
         <p:spPr>
           <a:xfrm>
-            <a:off x="8121244" y="1783080"/>
-            <a:ext cx="3429000" cy="2148840"/>
+            <a:off x="9058504" y="1965960"/>
+            <a:ext cx="2606040" cy="3429000"/>
           </a:xfrm>
           <a:prstGeom prst="roundRect">
             <a:avLst>
-              <a:gd name="adj" fmla="val 6000"/>
+              <a:gd name="adj" fmla="val 5000"/>
             </a:avLst>
           </a:prstGeom>
           <a:solidFill>
-            <a:srgbClr val="FFFFFF"/>
+            <a:srgbClr val="F2F7F4"/>
           </a:solidFill>
           <a:ln w="15875">
             <a:solidFill>
@@ -5866,148 +6309,250 @@
         </p:nvSpPr>
         <p:spPr>
           <a:xfrm>
-            <a:off x="9401404" y="2103120"/>
-            <a:ext cx="868680" cy="868680"/>
-          </a:xfrm>
-          <a:prstGeom prst="ellipse">
-            <a:avLst/>
-          </a:prstGeom>
-          <a:solidFill>
-            <a:srgbClr val="E4A11B"/>
-          </a:solidFill>
-        </p:spPr>
-        <p:txBody>
-          <a:bodyPr/>
-          <a:lstStyle/>
-          <a:p/>
-        </p:txBody>
-      </p:sp>
-      <p:sp>
-        <p:nvSpPr>
-          <p:cNvPr id="7" name="t7"/>
-          <p:cNvSpPr txBox="1"/>
-          <p:nvPr/>
-        </p:nvSpPr>
-        <p:spPr>
-          <a:xfrm>
-            <a:off x="9401404" y="2103120"/>
-            <a:ext cx="868680" cy="868680"/>
-          </a:xfrm>
-          <a:prstGeom prst="rect">
-            <a:avLst/>
-          </a:prstGeom>
-          <a:noFill/>
-        </p:spPr>
-        <p:txBody>
-          <a:bodyPr wrap="square" lIns="0" tIns="0" rIns="0" bIns="0" anchor="ctr" rtlCol="1">
-            <a:normAutofit/>
-          </a:bodyPr>
-          <a:lstStyle/>
-          <a:p>
-            <a:pPr algn="ctr" rtl="0"/>
-            <a:r>
-              <a:rPr lang="ar-SA" sz="3000" b="1" dirty="0">
-                <a:solidFill>
-                  <a:srgbClr val="FFFFFF"/>
-                </a:solidFill>
-                <a:latin typeface="Arial"/>
-                <a:cs typeface="Arial"/>
-              </a:rPr>
-              <a:t>★</a:t>
-            </a:r>
-          </a:p>
-        </p:txBody>
-      </p:sp>
-      <p:sp>
-        <p:nvSpPr>
-          <p:cNvPr id="8" name="t8"/>
-          <p:cNvSpPr txBox="1"/>
-          <p:nvPr/>
-        </p:nvSpPr>
-        <p:spPr>
-          <a:xfrm>
-            <a:off x="8304124" y="3081528"/>
-            <a:ext cx="3063240" cy="457200"/>
-          </a:xfrm>
-          <a:prstGeom prst="rect">
-            <a:avLst/>
-          </a:prstGeom>
-          <a:noFill/>
-        </p:spPr>
-        <p:txBody>
-          <a:bodyPr wrap="square" lIns="54864" tIns="18288" rIns="54864" bIns="18288" anchor="t" rtlCol="1">
-            <a:normAutofit/>
-          </a:bodyPr>
-          <a:lstStyle/>
-          <a:p>
-            <a:pPr algn="ctr" rtl="1"/>
-            <a:r>
-              <a:rPr lang="ar-SA" sz="2000" b="1" dirty="0">
-                <a:solidFill>
-                  <a:srgbClr val="17281F"/>
-                </a:solidFill>
-                <a:latin typeface="Arial"/>
-                <a:cs typeface="Arial"/>
-              </a:rPr>
-              <a:t>ذهبي</a:t>
-            </a:r>
-          </a:p>
-        </p:txBody>
-      </p:sp>
-      <p:sp>
-        <p:nvSpPr>
-          <p:cNvPr id="9" name="t9"/>
-          <p:cNvSpPr txBox="1"/>
-          <p:nvPr/>
-        </p:nvSpPr>
-        <p:spPr>
-          <a:xfrm>
-            <a:off x="8304124" y="3538728"/>
-            <a:ext cx="3063240" cy="365760"/>
-          </a:xfrm>
-          <a:prstGeom prst="rect">
-            <a:avLst/>
-          </a:prstGeom>
-          <a:noFill/>
-        </p:spPr>
-        <p:txBody>
-          <a:bodyPr wrap="square" lIns="54864" tIns="18288" rIns="54864" bIns="18288" anchor="t" rtlCol="1">
-            <a:normAutofit/>
-          </a:bodyPr>
-          <a:lstStyle/>
-          <a:p>
-            <a:pPr algn="ctr" rtl="1"/>
-            <a:r>
-              <a:rPr lang="ar-SA" sz="1350" dirty="0">
-                <a:solidFill>
-                  <a:srgbClr val="7C8B84"/>
-                </a:solidFill>
-                <a:latin typeface="Arial"/>
-                <a:cs typeface="Arial"/>
-              </a:rPr>
-              <a:t>المراكز الأولى</a:t>
-            </a:r>
-          </a:p>
-        </p:txBody>
-      </p:sp>
-      <p:sp>
-        <p:nvSpPr>
-          <p:cNvPr id="10" name="s10"/>
-          <p:cNvSpPr/>
-          <p:nvPr/>
-        </p:nvSpPr>
-        <p:spPr>
-          <a:xfrm>
-            <a:off x="4381348" y="1783080"/>
-            <a:ext cx="3429000" cy="2148840"/>
+            <a:off x="9469984" y="2240280"/>
+            <a:ext cx="1783080" cy="512064"/>
           </a:xfrm>
           <a:prstGeom prst="roundRect">
             <a:avLst>
-              <a:gd name="adj" fmla="val 6000"/>
+              <a:gd name="adj" fmla="val 28000"/>
             </a:avLst>
           </a:prstGeom>
           <a:solidFill>
-            <a:srgbClr val="FFFFFF"/>
+            <a:srgbClr val="E4A11B"/>
+          </a:solidFill>
+        </p:spPr>
+        <p:txBody>
+          <a:bodyPr/>
+          <a:lstStyle/>
+          <a:p/>
+        </p:txBody>
+      </p:sp>
+      <p:sp>
+        <p:nvSpPr>
+          <p:cNvPr id="7" name="t7"/>
+          <p:cNvSpPr txBox="1"/>
+          <p:nvPr/>
+        </p:nvSpPr>
+        <p:spPr>
+          <a:xfrm>
+            <a:off x="9469984" y="2240280"/>
+            <a:ext cx="1783080" cy="512064"/>
+          </a:xfrm>
+          <a:prstGeom prst="rect">
+            <a:avLst/>
+          </a:prstGeom>
+          <a:noFill/>
+        </p:spPr>
+        <p:txBody>
+          <a:bodyPr wrap="square" lIns="0" tIns="0" rIns="0" bIns="0" anchor="ctr" rtlCol="1">
+            <a:normAutofit/>
+          </a:bodyPr>
+          <a:lstStyle/>
+          <a:p>
+            <a:pPr algn="ctr" rtl="1"/>
+            <a:r>
+              <a:rPr lang="ar-SA" sz="1500" b="1" dirty="0">
+                <a:solidFill>
+                  <a:srgbClr val="FFFFFF"/>
+                </a:solidFill>
+                <a:latin typeface="Arial"/>
+                <a:cs typeface="Arial"/>
+              </a:rPr>
+              <a:t>150 نقطة</a:t>
+            </a:r>
+          </a:p>
+        </p:txBody>
+      </p:sp>
+      <p:sp>
+        <p:nvSpPr>
+          <p:cNvPr id="8" name="s8"/>
+          <p:cNvSpPr/>
+          <p:nvPr/>
+        </p:nvSpPr>
+        <p:spPr>
+          <a:xfrm>
+            <a:off x="9940900" y="2990088"/>
+            <a:ext cx="841248" cy="841248"/>
+          </a:xfrm>
+          <a:prstGeom prst="ellipse">
+            <a:avLst/>
+          </a:prstGeom>
+          <a:solidFill>
+            <a:srgbClr val="0F7A56"/>
+          </a:solidFill>
+        </p:spPr>
+        <p:txBody>
+          <a:bodyPr/>
+          <a:lstStyle/>
+          <a:p/>
+        </p:txBody>
+      </p:sp>
+      <p:sp>
+        <p:nvSpPr>
+          <p:cNvPr id="9" name="t9"/>
+          <p:cNvSpPr txBox="1"/>
+          <p:nvPr/>
+        </p:nvSpPr>
+        <p:spPr>
+          <a:xfrm>
+            <a:off x="9940900" y="2990088"/>
+            <a:ext cx="841248" cy="841248"/>
+          </a:xfrm>
+          <a:prstGeom prst="rect">
+            <a:avLst/>
+          </a:prstGeom>
+          <a:noFill/>
+        </p:spPr>
+        <p:txBody>
+          <a:bodyPr wrap="square" lIns="0" tIns="0" rIns="0" bIns="0" anchor="ctr" rtlCol="1">
+            <a:normAutofit/>
+          </a:bodyPr>
+          <a:lstStyle/>
+          <a:p>
+            <a:pPr algn="ctr" rtl="0"/>
+            <a:r>
+              <a:rPr lang="ar-SA" sz="2800" b="1" dirty="0">
+                <a:solidFill>
+                  <a:srgbClr val="FFFFFF"/>
+                </a:solidFill>
+                <a:latin typeface="Arial"/>
+                <a:cs typeface="Arial"/>
+              </a:rPr>
+              <a:t>★</a:t>
+            </a:r>
+          </a:p>
+        </p:txBody>
+      </p:sp>
+      <p:sp>
+        <p:nvSpPr>
+          <p:cNvPr id="10" name="t10"/>
+          <p:cNvSpPr txBox="1"/>
+          <p:nvPr/>
+        </p:nvSpPr>
+        <p:spPr>
+          <a:xfrm>
+            <a:off x="9195664" y="4014216"/>
+            <a:ext cx="2331720" cy="457200"/>
+          </a:xfrm>
+          <a:prstGeom prst="rect">
+            <a:avLst/>
+          </a:prstGeom>
+          <a:noFill/>
+        </p:spPr>
+        <p:txBody>
+          <a:bodyPr wrap="square" lIns="54864" tIns="18288" rIns="54864" bIns="18288" anchor="t" rtlCol="1">
+            <a:normAutofit/>
+          </a:bodyPr>
+          <a:lstStyle/>
+          <a:p>
+            <a:pPr algn="ctr" rtl="1"/>
+            <a:r>
+              <a:rPr lang="ar-SA" sz="1650" b="1" dirty="0">
+                <a:solidFill>
+                  <a:srgbClr val="17281F"/>
+                </a:solidFill>
+                <a:latin typeface="Arial"/>
+                <a:cs typeface="Arial"/>
+              </a:rPr>
+              <a:t>شهادة وشارة</a:t>
+            </a:r>
+          </a:p>
+        </p:txBody>
+      </p:sp>
+      <p:sp>
+        <p:nvSpPr>
+          <p:cNvPr id="11" name="t11"/>
+          <p:cNvSpPr txBox="1"/>
+          <p:nvPr/>
+        </p:nvSpPr>
+        <p:spPr>
+          <a:xfrm>
+            <a:off x="9259672" y="4507992"/>
+            <a:ext cx="2203704" cy="868680"/>
+          </a:xfrm>
+          <a:prstGeom prst="rect">
+            <a:avLst/>
+          </a:prstGeom>
+          <a:noFill/>
+        </p:spPr>
+        <p:txBody>
+          <a:bodyPr wrap="square" lIns="54864" tIns="36576" rIns="54864" bIns="36576" anchor="t" rtlCol="1">
+            <a:normAutofit/>
+          </a:bodyPr>
+          <a:lstStyle/>
+          <a:p>
+            <a:pPr algn="ctr" rtl="1">
+              <a:lnSpc>
+                <a:spcPct val="122000"/>
+              </a:lnSpc>
+            </a:pPr>
+            <a:r>
+              <a:rPr lang="ar-SA" sz="1250" dirty="0">
+                <a:solidFill>
+                  <a:srgbClr val="3E4C45"/>
+                </a:solidFill>
+                <a:latin typeface="Arial"/>
+                <a:cs typeface="Arial"/>
+              </a:rPr>
+              <a:t>شهادة شكر رقمية + شارة «مدرسة نشطة».</a:t>
+            </a:r>
+          </a:p>
+        </p:txBody>
+      </p:sp>
+      <p:sp>
+        <p:nvSpPr>
+          <p:cNvPr id="12" name="t12"/>
+          <p:cNvSpPr txBox="1"/>
+          <p:nvPr/>
+        </p:nvSpPr>
+        <p:spPr>
+          <a:xfrm>
+            <a:off x="8738464" y="3172968"/>
+            <a:ext cx="402336" cy="457200"/>
+          </a:xfrm>
+          <a:prstGeom prst="rect">
+            <a:avLst/>
+          </a:prstGeom>
+          <a:noFill/>
+        </p:spPr>
+        <p:txBody>
+          <a:bodyPr wrap="square" lIns="0" tIns="0" rIns="0" bIns="0" anchor="ctr" rtlCol="1">
+            <a:normAutofit/>
+          </a:bodyPr>
+          <a:lstStyle/>
+          <a:p>
+            <a:pPr algn="ctr" rtl="0"/>
+            <a:r>
+              <a:rPr lang="ar-SA" sz="2200" b="1" dirty="0">
+                <a:solidFill>
+                  <a:srgbClr val="E4A11B"/>
+                </a:solidFill>
+                <a:latin typeface="Arial"/>
+                <a:cs typeface="Arial"/>
+              </a:rPr>
+              <a:t>←</a:t>
+            </a:r>
+          </a:p>
+        </p:txBody>
+      </p:sp>
+      <p:sp>
+        <p:nvSpPr>
+          <p:cNvPr id="13" name="s13"/>
+          <p:cNvSpPr/>
+          <p:nvPr/>
+        </p:nvSpPr>
+        <p:spPr>
+          <a:xfrm>
+            <a:off x="6214720" y="1965960"/>
+            <a:ext cx="2606040" cy="3429000"/>
+          </a:xfrm>
+          <a:prstGeom prst="roundRect">
+            <a:avLst>
+              <a:gd name="adj" fmla="val 5000"/>
+            </a:avLst>
+          </a:prstGeom>
+          <a:solidFill>
+            <a:srgbClr val="F2F7F4"/>
           </a:solidFill>
           <a:ln w="15875">
             <a:solidFill>
@@ -6030,154 +6575,256 @@
       </p:sp>
       <p:sp>
         <p:nvSpPr>
-          <p:cNvPr id="11" name="s11"/>
-          <p:cNvSpPr/>
-          <p:nvPr/>
-        </p:nvSpPr>
-        <p:spPr>
-          <a:xfrm>
-            <a:off x="5661508" y="2103120"/>
-            <a:ext cx="868680" cy="868680"/>
-          </a:xfrm>
-          <a:prstGeom prst="ellipse">
-            <a:avLst/>
-          </a:prstGeom>
-          <a:solidFill>
-            <a:srgbClr val="9AA5A0"/>
-          </a:solidFill>
-        </p:spPr>
-        <p:txBody>
-          <a:bodyPr/>
-          <a:lstStyle/>
-          <a:p/>
-        </p:txBody>
-      </p:sp>
-      <p:sp>
-        <p:nvSpPr>
-          <p:cNvPr id="12" name="t12"/>
-          <p:cNvSpPr txBox="1"/>
-          <p:nvPr/>
-        </p:nvSpPr>
-        <p:spPr>
-          <a:xfrm>
-            <a:off x="5661508" y="2103120"/>
-            <a:ext cx="868680" cy="868680"/>
-          </a:xfrm>
-          <a:prstGeom prst="rect">
-            <a:avLst/>
-          </a:prstGeom>
-          <a:noFill/>
-        </p:spPr>
-        <p:txBody>
-          <a:bodyPr wrap="square" lIns="0" tIns="0" rIns="0" bIns="0" anchor="ctr" rtlCol="1">
-            <a:normAutofit/>
-          </a:bodyPr>
-          <a:lstStyle/>
-          <a:p>
-            <a:pPr algn="ctr" rtl="0"/>
-            <a:r>
-              <a:rPr lang="ar-SA" sz="3000" b="1" dirty="0">
-                <a:solidFill>
-                  <a:srgbClr val="FFFFFF"/>
-                </a:solidFill>
-                <a:latin typeface="Arial"/>
-                <a:cs typeface="Arial"/>
-              </a:rPr>
-              <a:t>★</a:t>
-            </a:r>
-          </a:p>
-        </p:txBody>
-      </p:sp>
-      <p:sp>
-        <p:nvSpPr>
-          <p:cNvPr id="13" name="t13"/>
-          <p:cNvSpPr txBox="1"/>
-          <p:nvPr/>
-        </p:nvSpPr>
-        <p:spPr>
-          <a:xfrm>
-            <a:off x="4564228" y="3081528"/>
-            <a:ext cx="3063240" cy="457200"/>
-          </a:xfrm>
-          <a:prstGeom prst="rect">
-            <a:avLst/>
-          </a:prstGeom>
-          <a:noFill/>
-        </p:spPr>
-        <p:txBody>
-          <a:bodyPr wrap="square" lIns="54864" tIns="18288" rIns="54864" bIns="18288" anchor="t" rtlCol="1">
-            <a:normAutofit/>
-          </a:bodyPr>
-          <a:lstStyle/>
-          <a:p>
-            <a:pPr algn="ctr" rtl="1"/>
-            <a:r>
-              <a:rPr lang="ar-SA" sz="2000" b="1" dirty="0">
-                <a:solidFill>
-                  <a:srgbClr val="17281F"/>
-                </a:solidFill>
-                <a:latin typeface="Arial"/>
-                <a:cs typeface="Arial"/>
-              </a:rPr>
-              <a:t>فضّي</a:t>
-            </a:r>
-          </a:p>
-        </p:txBody>
-      </p:sp>
-      <p:sp>
-        <p:nvSpPr>
-          <p:cNvPr id="14" name="t14"/>
-          <p:cNvSpPr txBox="1"/>
-          <p:nvPr/>
-        </p:nvSpPr>
-        <p:spPr>
-          <a:xfrm>
-            <a:off x="4564228" y="3538728"/>
-            <a:ext cx="3063240" cy="365760"/>
-          </a:xfrm>
-          <a:prstGeom prst="rect">
-            <a:avLst/>
-          </a:prstGeom>
-          <a:noFill/>
-        </p:spPr>
-        <p:txBody>
-          <a:bodyPr wrap="square" lIns="54864" tIns="18288" rIns="54864" bIns="18288" anchor="t" rtlCol="1">
-            <a:normAutofit/>
-          </a:bodyPr>
-          <a:lstStyle/>
-          <a:p>
-            <a:pPr algn="ctr" rtl="1"/>
-            <a:r>
-              <a:rPr lang="ar-SA" sz="1350" dirty="0">
-                <a:solidFill>
-                  <a:srgbClr val="7C8B84"/>
-                </a:solidFill>
-                <a:latin typeface="Arial"/>
-                <a:cs typeface="Arial"/>
-              </a:rPr>
-              <a:t>المراكز المتوسطة</a:t>
-            </a:r>
-          </a:p>
-        </p:txBody>
-      </p:sp>
-      <p:sp>
-        <p:nvSpPr>
-          <p:cNvPr id="15" name="s15"/>
-          <p:cNvSpPr/>
-          <p:nvPr/>
-        </p:nvSpPr>
-        <p:spPr>
-          <a:xfrm>
-            <a:off x="641452" y="1783080"/>
-            <a:ext cx="3429000" cy="2148840"/>
+          <p:cNvPr id="14" name="s14"/>
+          <p:cNvSpPr/>
+          <p:nvPr/>
+        </p:nvSpPr>
+        <p:spPr>
+          <a:xfrm>
+            <a:off x="6626200" y="2240280"/>
+            <a:ext cx="1783080" cy="512064"/>
           </a:xfrm>
           <a:prstGeom prst="roundRect">
             <a:avLst>
-              <a:gd name="adj" fmla="val 6000"/>
+              <a:gd name="adj" fmla="val 28000"/>
             </a:avLst>
           </a:prstGeom>
           <a:solidFill>
-            <a:srgbClr val="FFFFFF"/>
+            <a:srgbClr val="E4A11B"/>
+          </a:solidFill>
+        </p:spPr>
+        <p:txBody>
+          <a:bodyPr/>
+          <a:lstStyle/>
+          <a:p/>
+        </p:txBody>
+      </p:sp>
+      <p:sp>
+        <p:nvSpPr>
+          <p:cNvPr id="15" name="t15"/>
+          <p:cNvSpPr txBox="1"/>
+          <p:nvPr/>
+        </p:nvSpPr>
+        <p:spPr>
+          <a:xfrm>
+            <a:off x="6626200" y="2240280"/>
+            <a:ext cx="1783080" cy="512064"/>
+          </a:xfrm>
+          <a:prstGeom prst="rect">
+            <a:avLst/>
+          </a:prstGeom>
+          <a:noFill/>
+        </p:spPr>
+        <p:txBody>
+          <a:bodyPr wrap="square" lIns="0" tIns="0" rIns="0" bIns="0" anchor="ctr" rtlCol="1">
+            <a:normAutofit/>
+          </a:bodyPr>
+          <a:lstStyle/>
+          <a:p>
+            <a:pPr algn="ctr" rtl="1"/>
+            <a:r>
+              <a:rPr lang="ar-SA" sz="1500" b="1" dirty="0">
+                <a:solidFill>
+                  <a:srgbClr val="FFFFFF"/>
+                </a:solidFill>
+                <a:latin typeface="Arial"/>
+                <a:cs typeface="Arial"/>
+              </a:rPr>
+              <a:t>350 نقطة</a:t>
+            </a:r>
+          </a:p>
+        </p:txBody>
+      </p:sp>
+      <p:sp>
+        <p:nvSpPr>
+          <p:cNvPr id="16" name="s16"/>
+          <p:cNvSpPr/>
+          <p:nvPr/>
+        </p:nvSpPr>
+        <p:spPr>
+          <a:xfrm>
+            <a:off x="7097116" y="2990088"/>
+            <a:ext cx="841248" cy="841248"/>
+          </a:xfrm>
+          <a:prstGeom prst="ellipse">
+            <a:avLst/>
+          </a:prstGeom>
+          <a:solidFill>
+            <a:srgbClr val="0F7A56"/>
+          </a:solidFill>
+        </p:spPr>
+        <p:txBody>
+          <a:bodyPr/>
+          <a:lstStyle/>
+          <a:p/>
+        </p:txBody>
+      </p:sp>
+      <p:sp>
+        <p:nvSpPr>
+          <p:cNvPr id="17" name="t17"/>
+          <p:cNvSpPr txBox="1"/>
+          <p:nvPr/>
+        </p:nvSpPr>
+        <p:spPr>
+          <a:xfrm>
+            <a:off x="7097116" y="2990088"/>
+            <a:ext cx="841248" cy="841248"/>
+          </a:xfrm>
+          <a:prstGeom prst="rect">
+            <a:avLst/>
+          </a:prstGeom>
+          <a:noFill/>
+        </p:spPr>
+        <p:txBody>
+          <a:bodyPr wrap="square" lIns="0" tIns="0" rIns="0" bIns="0" anchor="ctr" rtlCol="1">
+            <a:normAutofit/>
+          </a:bodyPr>
+          <a:lstStyle/>
+          <a:p>
+            <a:pPr algn="ctr" rtl="0"/>
+            <a:r>
+              <a:rPr lang="ar-SA" sz="2800" b="1" dirty="0">
+                <a:solidFill>
+                  <a:srgbClr val="FFFFFF"/>
+                </a:solidFill>
+                <a:latin typeface="Arial"/>
+                <a:cs typeface="Arial"/>
+              </a:rPr>
+              <a:t>●</a:t>
+            </a:r>
+          </a:p>
+        </p:txBody>
+      </p:sp>
+      <p:sp>
+        <p:nvSpPr>
+          <p:cNvPr id="18" name="t18"/>
+          <p:cNvSpPr txBox="1"/>
+          <p:nvPr/>
+        </p:nvSpPr>
+        <p:spPr>
+          <a:xfrm>
+            <a:off x="6351880" y="4014216"/>
+            <a:ext cx="2331720" cy="457200"/>
+          </a:xfrm>
+          <a:prstGeom prst="rect">
+            <a:avLst/>
+          </a:prstGeom>
+          <a:noFill/>
+        </p:spPr>
+        <p:txBody>
+          <a:bodyPr wrap="square" lIns="54864" tIns="18288" rIns="54864" bIns="18288" anchor="t" rtlCol="1">
+            <a:normAutofit/>
+          </a:bodyPr>
+          <a:lstStyle/>
+          <a:p>
+            <a:pPr algn="ctr" rtl="1"/>
+            <a:r>
+              <a:rPr lang="ar-SA" sz="1650" b="1" dirty="0">
+                <a:solidFill>
+                  <a:srgbClr val="17281F"/>
+                </a:solidFill>
+                <a:latin typeface="Arial"/>
+                <a:cs typeface="Arial"/>
+              </a:rPr>
+              <a:t>ضيف مُلهِم</a:t>
+            </a:r>
+          </a:p>
+        </p:txBody>
+      </p:sp>
+      <p:sp>
+        <p:nvSpPr>
+          <p:cNvPr id="19" name="t19"/>
+          <p:cNvSpPr txBox="1"/>
+          <p:nvPr/>
+        </p:nvSpPr>
+        <p:spPr>
+          <a:xfrm>
+            <a:off x="6415888" y="4507992"/>
+            <a:ext cx="2203704" cy="868680"/>
+          </a:xfrm>
+          <a:prstGeom prst="rect">
+            <a:avLst/>
+          </a:prstGeom>
+          <a:noFill/>
+        </p:spPr>
+        <p:txBody>
+          <a:bodyPr wrap="square" lIns="54864" tIns="36576" rIns="54864" bIns="36576" anchor="t" rtlCol="1">
+            <a:normAutofit/>
+          </a:bodyPr>
+          <a:lstStyle/>
+          <a:p>
+            <a:pPr algn="ctr" rtl="1">
+              <a:lnSpc>
+                <a:spcPct val="122000"/>
+              </a:lnSpc>
+            </a:pPr>
+            <a:r>
+              <a:rPr lang="ar-SA" sz="1250" dirty="0">
+                <a:solidFill>
+                  <a:srgbClr val="3E4C45"/>
+                </a:solidFill>
+                <a:latin typeface="Arial"/>
+                <a:cs typeface="Arial"/>
+              </a:rPr>
+              <a:t>زيارة لاعب سابق من المنتخب الوطني للمدرسة.</a:t>
+            </a:r>
+          </a:p>
+        </p:txBody>
+      </p:sp>
+      <p:sp>
+        <p:nvSpPr>
+          <p:cNvPr id="20" name="t20"/>
+          <p:cNvSpPr txBox="1"/>
+          <p:nvPr/>
+        </p:nvSpPr>
+        <p:spPr>
+          <a:xfrm>
+            <a:off x="5894680" y="3172968"/>
+            <a:ext cx="402336" cy="457200"/>
+          </a:xfrm>
+          <a:prstGeom prst="rect">
+            <a:avLst/>
+          </a:prstGeom>
+          <a:noFill/>
+        </p:spPr>
+        <p:txBody>
+          <a:bodyPr wrap="square" lIns="0" tIns="0" rIns="0" bIns="0" anchor="ctr" rtlCol="1">
+            <a:normAutofit/>
+          </a:bodyPr>
+          <a:lstStyle/>
+          <a:p>
+            <a:pPr algn="ctr" rtl="0"/>
+            <a:r>
+              <a:rPr lang="ar-SA" sz="2200" b="1" dirty="0">
+                <a:solidFill>
+                  <a:srgbClr val="E4A11B"/>
+                </a:solidFill>
+                <a:latin typeface="Arial"/>
+                <a:cs typeface="Arial"/>
+              </a:rPr>
+              <a:t>←</a:t>
+            </a:r>
+          </a:p>
+        </p:txBody>
+      </p:sp>
+      <p:sp>
+        <p:nvSpPr>
+          <p:cNvPr id="21" name="s21"/>
+          <p:cNvSpPr/>
+          <p:nvPr/>
+        </p:nvSpPr>
+        <p:spPr>
+          <a:xfrm>
+            <a:off x="3370936" y="1965960"/>
+            <a:ext cx="2606040" cy="3429000"/>
+          </a:xfrm>
+          <a:prstGeom prst="roundRect">
+            <a:avLst>
+              <a:gd name="adj" fmla="val 5000"/>
+            </a:avLst>
+          </a:prstGeom>
+          <a:solidFill>
+            <a:srgbClr val="F2F7F4"/>
           </a:solidFill>
           <a:ln w="15875">
             <a:solidFill>
@@ -6200,172 +6847,408 @@
       </p:sp>
       <p:sp>
         <p:nvSpPr>
-          <p:cNvPr id="16" name="s16"/>
-          <p:cNvSpPr/>
-          <p:nvPr/>
-        </p:nvSpPr>
-        <p:spPr>
-          <a:xfrm>
-            <a:off x="1921612" y="2103120"/>
-            <a:ext cx="868680" cy="868680"/>
-          </a:xfrm>
-          <a:prstGeom prst="ellipse">
-            <a:avLst/>
-          </a:prstGeom>
-          <a:solidFill>
-            <a:srgbClr val="B4794A"/>
-          </a:solidFill>
-        </p:spPr>
-        <p:txBody>
-          <a:bodyPr/>
-          <a:lstStyle/>
-          <a:p/>
-        </p:txBody>
-      </p:sp>
-      <p:sp>
-        <p:nvSpPr>
-          <p:cNvPr id="17" name="t17"/>
-          <p:cNvSpPr txBox="1"/>
-          <p:nvPr/>
-        </p:nvSpPr>
-        <p:spPr>
-          <a:xfrm>
-            <a:off x="1921612" y="2103120"/>
-            <a:ext cx="868680" cy="868680"/>
-          </a:xfrm>
-          <a:prstGeom prst="rect">
-            <a:avLst/>
-          </a:prstGeom>
-          <a:noFill/>
-        </p:spPr>
-        <p:txBody>
-          <a:bodyPr wrap="square" lIns="0" tIns="0" rIns="0" bIns="0" anchor="ctr" rtlCol="1">
-            <a:normAutofit/>
-          </a:bodyPr>
-          <a:lstStyle/>
-          <a:p>
-            <a:pPr algn="ctr" rtl="0"/>
-            <a:r>
-              <a:rPr lang="ar-SA" sz="3000" b="1" dirty="0">
-                <a:solidFill>
-                  <a:srgbClr val="FFFFFF"/>
-                </a:solidFill>
-                <a:latin typeface="Arial"/>
-                <a:cs typeface="Arial"/>
-              </a:rPr>
-              <a:t>★</a:t>
-            </a:r>
-          </a:p>
-        </p:txBody>
-      </p:sp>
-      <p:sp>
-        <p:nvSpPr>
-          <p:cNvPr id="18" name="t18"/>
-          <p:cNvSpPr txBox="1"/>
-          <p:nvPr/>
-        </p:nvSpPr>
-        <p:spPr>
-          <a:xfrm>
-            <a:off x="824332" y="3081528"/>
-            <a:ext cx="3063240" cy="457200"/>
-          </a:xfrm>
-          <a:prstGeom prst="rect">
-            <a:avLst/>
-          </a:prstGeom>
-          <a:noFill/>
-        </p:spPr>
-        <p:txBody>
-          <a:bodyPr wrap="square" lIns="54864" tIns="18288" rIns="54864" bIns="18288" anchor="t" rtlCol="1">
-            <a:normAutofit/>
-          </a:bodyPr>
-          <a:lstStyle/>
-          <a:p>
-            <a:pPr algn="ctr" rtl="1"/>
-            <a:r>
-              <a:rPr lang="ar-SA" sz="2000" b="1" dirty="0">
-                <a:solidFill>
-                  <a:srgbClr val="17281F"/>
-                </a:solidFill>
-                <a:latin typeface="Arial"/>
-                <a:cs typeface="Arial"/>
-              </a:rPr>
-              <a:t>برونزي</a:t>
-            </a:r>
-          </a:p>
-        </p:txBody>
-      </p:sp>
-      <p:sp>
-        <p:nvSpPr>
-          <p:cNvPr id="19" name="t19"/>
-          <p:cNvSpPr txBox="1"/>
-          <p:nvPr/>
-        </p:nvSpPr>
-        <p:spPr>
-          <a:xfrm>
-            <a:off x="824332" y="3538728"/>
-            <a:ext cx="3063240" cy="365760"/>
-          </a:xfrm>
-          <a:prstGeom prst="rect">
-            <a:avLst/>
-          </a:prstGeom>
-          <a:noFill/>
-        </p:spPr>
-        <p:txBody>
-          <a:bodyPr wrap="square" lIns="54864" tIns="18288" rIns="54864" bIns="18288" anchor="t" rtlCol="1">
-            <a:normAutofit/>
-          </a:bodyPr>
-          <a:lstStyle/>
-          <a:p>
-            <a:pPr algn="ctr" rtl="1"/>
-            <a:r>
-              <a:rPr lang="ar-SA" sz="1350" dirty="0">
-                <a:solidFill>
-                  <a:srgbClr val="7C8B84"/>
-                </a:solidFill>
-                <a:latin typeface="Arial"/>
-                <a:cs typeface="Arial"/>
-              </a:rPr>
-              <a:t>المشاركة الفاعلة</a:t>
-            </a:r>
-          </a:p>
-        </p:txBody>
-      </p:sp>
-      <p:sp>
-        <p:nvSpPr>
-          <p:cNvPr id="20" name="s20"/>
-          <p:cNvSpPr/>
-          <p:nvPr/>
-        </p:nvSpPr>
-        <p:spPr>
-          <a:xfrm>
-            <a:off x="640080" y="4206240"/>
-            <a:ext cx="10908792" cy="2011680"/>
+          <p:cNvPr id="22" name="s22"/>
+          <p:cNvSpPr/>
+          <p:nvPr/>
+        </p:nvSpPr>
+        <p:spPr>
+          <a:xfrm>
+            <a:off x="3782416" y="2240280"/>
+            <a:ext cx="1783080" cy="512064"/>
           </a:xfrm>
           <a:prstGeom prst="roundRect">
             <a:avLst>
-              <a:gd name="adj" fmla="val 4000"/>
+              <a:gd name="adj" fmla="val 28000"/>
             </a:avLst>
           </a:prstGeom>
           <a:solidFill>
+            <a:srgbClr val="E4A11B"/>
+          </a:solidFill>
+        </p:spPr>
+        <p:txBody>
+          <a:bodyPr/>
+          <a:lstStyle/>
+          <a:p/>
+        </p:txBody>
+      </p:sp>
+      <p:sp>
+        <p:nvSpPr>
+          <p:cNvPr id="23" name="t23"/>
+          <p:cNvSpPr txBox="1"/>
+          <p:nvPr/>
+        </p:nvSpPr>
+        <p:spPr>
+          <a:xfrm>
+            <a:off x="3782416" y="2240280"/>
+            <a:ext cx="1783080" cy="512064"/>
+          </a:xfrm>
+          <a:prstGeom prst="rect">
+            <a:avLst/>
+          </a:prstGeom>
+          <a:noFill/>
+        </p:spPr>
+        <p:txBody>
+          <a:bodyPr wrap="square" lIns="0" tIns="0" rIns="0" bIns="0" anchor="ctr" rtlCol="1">
+            <a:normAutofit/>
+          </a:bodyPr>
+          <a:lstStyle/>
+          <a:p>
+            <a:pPr algn="ctr" rtl="1"/>
+            <a:r>
+              <a:rPr lang="ar-SA" sz="1500" b="1" dirty="0">
+                <a:solidFill>
+                  <a:srgbClr val="FFFFFF"/>
+                </a:solidFill>
+                <a:latin typeface="Arial"/>
+                <a:cs typeface="Arial"/>
+              </a:rPr>
+              <a:t>650 نقطة</a:t>
+            </a:r>
+          </a:p>
+        </p:txBody>
+      </p:sp>
+      <p:sp>
+        <p:nvSpPr>
+          <p:cNvPr id="24" name="s24"/>
+          <p:cNvSpPr/>
+          <p:nvPr/>
+        </p:nvSpPr>
+        <p:spPr>
+          <a:xfrm>
+            <a:off x="4253332" y="2990088"/>
+            <a:ext cx="841248" cy="841248"/>
+          </a:xfrm>
+          <a:prstGeom prst="ellipse">
+            <a:avLst/>
+          </a:prstGeom>
+          <a:solidFill>
+            <a:srgbClr val="0F7A56"/>
+          </a:solidFill>
+        </p:spPr>
+        <p:txBody>
+          <a:bodyPr/>
+          <a:lstStyle/>
+          <a:p/>
+        </p:txBody>
+      </p:sp>
+      <p:sp>
+        <p:nvSpPr>
+          <p:cNvPr id="25" name="t25"/>
+          <p:cNvSpPr txBox="1"/>
+          <p:nvPr/>
+        </p:nvSpPr>
+        <p:spPr>
+          <a:xfrm>
+            <a:off x="4253332" y="2990088"/>
+            <a:ext cx="841248" cy="841248"/>
+          </a:xfrm>
+          <a:prstGeom prst="rect">
+            <a:avLst/>
+          </a:prstGeom>
+          <a:noFill/>
+        </p:spPr>
+        <p:txBody>
+          <a:bodyPr wrap="square" lIns="0" tIns="0" rIns="0" bIns="0" anchor="ctr" rtlCol="1">
+            <a:normAutofit/>
+          </a:bodyPr>
+          <a:lstStyle/>
+          <a:p>
+            <a:pPr algn="ctr" rtl="0"/>
+            <a:r>
+              <a:rPr lang="ar-SA" sz="2800" b="1" dirty="0">
+                <a:solidFill>
+                  <a:srgbClr val="FFFFFF"/>
+                </a:solidFill>
+                <a:latin typeface="Arial"/>
+                <a:cs typeface="Arial"/>
+              </a:rPr>
+              <a:t>◆</a:t>
+            </a:r>
+          </a:p>
+        </p:txBody>
+      </p:sp>
+      <p:sp>
+        <p:nvSpPr>
+          <p:cNvPr id="26" name="t26"/>
+          <p:cNvSpPr txBox="1"/>
+          <p:nvPr/>
+        </p:nvSpPr>
+        <p:spPr>
+          <a:xfrm>
+            <a:off x="3508096" y="4014216"/>
+            <a:ext cx="2331720" cy="457200"/>
+          </a:xfrm>
+          <a:prstGeom prst="rect">
+            <a:avLst/>
+          </a:prstGeom>
+          <a:noFill/>
+        </p:spPr>
+        <p:txBody>
+          <a:bodyPr wrap="square" lIns="54864" tIns="18288" rIns="54864" bIns="18288" anchor="t" rtlCol="1">
+            <a:normAutofit/>
+          </a:bodyPr>
+          <a:lstStyle/>
+          <a:p>
+            <a:pPr algn="ctr" rtl="1"/>
+            <a:r>
+              <a:rPr lang="ar-SA" sz="1650" b="1" dirty="0">
+                <a:solidFill>
+                  <a:srgbClr val="17281F"/>
+                </a:solidFill>
+                <a:latin typeface="Arial"/>
+                <a:cs typeface="Arial"/>
+              </a:rPr>
+              <a:t>نجم المنتخب</a:t>
+            </a:r>
+          </a:p>
+        </p:txBody>
+      </p:sp>
+      <p:sp>
+        <p:nvSpPr>
+          <p:cNvPr id="27" name="t27"/>
+          <p:cNvSpPr txBox="1"/>
+          <p:nvPr/>
+        </p:nvSpPr>
+        <p:spPr>
+          <a:xfrm>
+            <a:off x="3572104" y="4507992"/>
+            <a:ext cx="2203704" cy="868680"/>
+          </a:xfrm>
+          <a:prstGeom prst="rect">
+            <a:avLst/>
+          </a:prstGeom>
+          <a:noFill/>
+        </p:spPr>
+        <p:txBody>
+          <a:bodyPr wrap="square" lIns="54864" tIns="36576" rIns="54864" bIns="36576" anchor="t" rtlCol="1">
+            <a:normAutofit/>
+          </a:bodyPr>
+          <a:lstStyle/>
+          <a:p>
+            <a:pPr algn="ctr" rtl="1">
+              <a:lnSpc>
+                <a:spcPct val="122000"/>
+              </a:lnSpc>
+            </a:pPr>
+            <a:r>
+              <a:rPr lang="ar-SA" sz="1250" dirty="0">
+                <a:solidFill>
+                  <a:srgbClr val="3E4C45"/>
+                </a:solidFill>
+                <a:latin typeface="Arial"/>
+                <a:cs typeface="Arial"/>
+              </a:rPr>
+              <a:t>زيارة لاعب من المنتخب الحالي + حصة تدريبية معه.</a:t>
+            </a:r>
+          </a:p>
+        </p:txBody>
+      </p:sp>
+      <p:sp>
+        <p:nvSpPr>
+          <p:cNvPr id="28" name="t28"/>
+          <p:cNvSpPr txBox="1"/>
+          <p:nvPr/>
+        </p:nvSpPr>
+        <p:spPr>
+          <a:xfrm>
+            <a:off x="3050896" y="3172968"/>
+            <a:ext cx="402336" cy="457200"/>
+          </a:xfrm>
+          <a:prstGeom prst="rect">
+            <a:avLst/>
+          </a:prstGeom>
+          <a:noFill/>
+        </p:spPr>
+        <p:txBody>
+          <a:bodyPr wrap="square" lIns="0" tIns="0" rIns="0" bIns="0" anchor="ctr" rtlCol="1">
+            <a:normAutofit/>
+          </a:bodyPr>
+          <a:lstStyle/>
+          <a:p>
+            <a:pPr algn="ctr" rtl="0"/>
+            <a:r>
+              <a:rPr lang="ar-SA" sz="2200" b="1" dirty="0">
+                <a:solidFill>
+                  <a:srgbClr val="E4A11B"/>
+                </a:solidFill>
+                <a:latin typeface="Arial"/>
+                <a:cs typeface="Arial"/>
+              </a:rPr>
+              <a:t>←</a:t>
+            </a:r>
+          </a:p>
+        </p:txBody>
+      </p:sp>
+      <p:sp>
+        <p:nvSpPr>
+          <p:cNvPr id="29" name="s29"/>
+          <p:cNvSpPr/>
+          <p:nvPr/>
+        </p:nvSpPr>
+        <p:spPr>
+          <a:xfrm>
+            <a:off x="527152" y="1965960"/>
+            <a:ext cx="2606040" cy="3429000"/>
+          </a:xfrm>
+          <a:prstGeom prst="roundRect">
+            <a:avLst>
+              <a:gd name="adj" fmla="val 5000"/>
+            </a:avLst>
+          </a:prstGeom>
+          <a:solidFill>
             <a:srgbClr val="F2F7F4"/>
           </a:solidFill>
-        </p:spPr>
-        <p:txBody>
-          <a:bodyPr/>
-          <a:lstStyle/>
-          <a:p/>
-        </p:txBody>
-      </p:sp>
-      <p:sp>
-        <p:nvSpPr>
-          <p:cNvPr id="21" name="t21"/>
-          <p:cNvSpPr txBox="1"/>
-          <p:nvPr/>
-        </p:nvSpPr>
-        <p:spPr>
-          <a:xfrm>
-            <a:off x="868680" y="4389120"/>
-            <a:ext cx="10424160" cy="457200"/>
+          <a:ln w="15875">
+            <a:solidFill>
+              <a:srgbClr val="D6E4DC"/>
+            </a:solidFill>
+          </a:ln>
+          <a:effectLst>
+            <a:outerShdw blurRad="90000" dist="38100" dir="5400000" rotWithShape="0">
+              <a:srgbClr val="0C3B2E">
+                <a:alpha val="20000"/>
+              </a:srgbClr>
+            </a:outerShdw>
+          </a:effectLst>
+        </p:spPr>
+        <p:txBody>
+          <a:bodyPr/>
+          <a:lstStyle/>
+          <a:p/>
+        </p:txBody>
+      </p:sp>
+      <p:sp>
+        <p:nvSpPr>
+          <p:cNvPr id="30" name="s30"/>
+          <p:cNvSpPr/>
+          <p:nvPr/>
+        </p:nvSpPr>
+        <p:spPr>
+          <a:xfrm>
+            <a:off x="938632" y="2240280"/>
+            <a:ext cx="1783080" cy="512064"/>
+          </a:xfrm>
+          <a:prstGeom prst="roundRect">
+            <a:avLst>
+              <a:gd name="adj" fmla="val 28000"/>
+            </a:avLst>
+          </a:prstGeom>
+          <a:solidFill>
+            <a:srgbClr val="E4A11B"/>
+          </a:solidFill>
+        </p:spPr>
+        <p:txBody>
+          <a:bodyPr/>
+          <a:lstStyle/>
+          <a:p/>
+        </p:txBody>
+      </p:sp>
+      <p:sp>
+        <p:nvSpPr>
+          <p:cNvPr id="31" name="t31"/>
+          <p:cNvSpPr txBox="1"/>
+          <p:nvPr/>
+        </p:nvSpPr>
+        <p:spPr>
+          <a:xfrm>
+            <a:off x="938632" y="2240280"/>
+            <a:ext cx="1783080" cy="512064"/>
+          </a:xfrm>
+          <a:prstGeom prst="rect">
+            <a:avLst/>
+          </a:prstGeom>
+          <a:noFill/>
+        </p:spPr>
+        <p:txBody>
+          <a:bodyPr wrap="square" lIns="0" tIns="0" rIns="0" bIns="0" anchor="ctr" rtlCol="1">
+            <a:normAutofit/>
+          </a:bodyPr>
+          <a:lstStyle/>
+          <a:p>
+            <a:pPr algn="ctr" rtl="1"/>
+            <a:r>
+              <a:rPr lang="ar-SA" sz="1500" b="1" dirty="0">
+                <a:solidFill>
+                  <a:srgbClr val="FFFFFF"/>
+                </a:solidFill>
+                <a:latin typeface="Arial"/>
+                <a:cs typeface="Arial"/>
+              </a:rPr>
+              <a:t>1000 نقطة</a:t>
+            </a:r>
+          </a:p>
+        </p:txBody>
+      </p:sp>
+      <p:sp>
+        <p:nvSpPr>
+          <p:cNvPr id="32" name="s32"/>
+          <p:cNvSpPr/>
+          <p:nvPr/>
+        </p:nvSpPr>
+        <p:spPr>
+          <a:xfrm>
+            <a:off x="1409548" y="2990088"/>
+            <a:ext cx="841248" cy="841248"/>
+          </a:xfrm>
+          <a:prstGeom prst="ellipse">
+            <a:avLst/>
+          </a:prstGeom>
+          <a:solidFill>
+            <a:srgbClr val="0F7A56"/>
+          </a:solidFill>
+        </p:spPr>
+        <p:txBody>
+          <a:bodyPr/>
+          <a:lstStyle/>
+          <a:p/>
+        </p:txBody>
+      </p:sp>
+      <p:sp>
+        <p:nvSpPr>
+          <p:cNvPr id="33" name="t33"/>
+          <p:cNvSpPr txBox="1"/>
+          <p:nvPr/>
+        </p:nvSpPr>
+        <p:spPr>
+          <a:xfrm>
+            <a:off x="1409548" y="2990088"/>
+            <a:ext cx="841248" cy="841248"/>
+          </a:xfrm>
+          <a:prstGeom prst="rect">
+            <a:avLst/>
+          </a:prstGeom>
+          <a:noFill/>
+        </p:spPr>
+        <p:txBody>
+          <a:bodyPr wrap="square" lIns="0" tIns="0" rIns="0" bIns="0" anchor="ctr" rtlCol="1">
+            <a:normAutofit/>
+          </a:bodyPr>
+          <a:lstStyle/>
+          <a:p>
+            <a:pPr algn="ctr" rtl="0"/>
+            <a:r>
+              <a:rPr lang="ar-SA" sz="2800" b="1" dirty="0">
+                <a:solidFill>
+                  <a:srgbClr val="FFFFFF"/>
+                </a:solidFill>
+                <a:latin typeface="Arial"/>
+                <a:cs typeface="Arial"/>
+              </a:rPr>
+              <a:t>▲</a:t>
+            </a:r>
+          </a:p>
+        </p:txBody>
+      </p:sp>
+      <p:sp>
+        <p:nvSpPr>
+          <p:cNvPr id="34" name="t34"/>
+          <p:cNvSpPr txBox="1"/>
+          <p:nvPr/>
+        </p:nvSpPr>
+        <p:spPr>
+          <a:xfrm>
+            <a:off x="664312" y="4014216"/>
+            <a:ext cx="2331720" cy="457200"/>
           </a:xfrm>
           <a:prstGeom prst="rect">
             <a:avLst/>
@@ -6378,30 +7261,30 @@
           </a:bodyPr>
           <a:lstStyle/>
           <a:p>
-            <a:pPr algn="r" rtl="1"/>
-            <a:r>
-              <a:rPr lang="ar-SA" sz="1600" b="1" dirty="0">
-                <a:solidFill>
-                  <a:srgbClr val="0F7A56"/>
-                </a:solidFill>
-                <a:latin typeface="Arial"/>
-                <a:cs typeface="Arial"/>
-              </a:rPr>
-              <a:t>أنواع المكافآت</a:t>
-            </a:r>
-          </a:p>
-        </p:txBody>
-      </p:sp>
-      <p:sp>
-        <p:nvSpPr>
-          <p:cNvPr id="22" name="t22"/>
-          <p:cNvSpPr txBox="1"/>
-          <p:nvPr/>
-        </p:nvSpPr>
-        <p:spPr>
-          <a:xfrm>
-            <a:off x="6248095" y="4892040"/>
-            <a:ext cx="5074920" cy="502920"/>
+            <a:pPr algn="ctr" rtl="1"/>
+            <a:r>
+              <a:rPr lang="ar-SA" sz="1650" b="1" dirty="0">
+                <a:solidFill>
+                  <a:srgbClr val="17281F"/>
+                </a:solidFill>
+                <a:latin typeface="Arial"/>
+                <a:cs typeface="Arial"/>
+              </a:rPr>
+              <a:t>على طاولة المدرب</a:t>
+            </a:r>
+          </a:p>
+        </p:txBody>
+      </p:sp>
+      <p:sp>
+        <p:nvSpPr>
+          <p:cNvPr id="35" name="t35"/>
+          <p:cNvSpPr txBox="1"/>
+          <p:nvPr/>
+        </p:nvSpPr>
+        <p:spPr>
+          <a:xfrm>
+            <a:off x="728320" y="4507992"/>
+            <a:ext cx="2203704" cy="868680"/>
           </a:xfrm>
           <a:prstGeom prst="rect">
             <a:avLst/>
@@ -6414,148 +7297,92 @@
           </a:bodyPr>
           <a:lstStyle/>
           <a:p>
-            <a:pPr marL="310896" indent="-310896" algn="r" rtl="1">
-              <a:buClr>
-                <a:srgbClr val="0F7A56"/>
-              </a:buClr>
-              <a:buFont typeface="Arial"/>
-              <a:buChar char="✓"/>
+            <a:pPr algn="ctr" rtl="1">
+              <a:lnSpc>
+                <a:spcPct val="122000"/>
+              </a:lnSpc>
             </a:pPr>
             <a:r>
-              <a:rPr lang="ar-SA" sz="1400" dirty="0">
-                <a:solidFill>
-                  <a:srgbClr val="17281F"/>
-                </a:solidFill>
-                <a:latin typeface="Arial"/>
-                <a:cs typeface="Arial"/>
-              </a:rPr>
-              <a:t>دروع وشهادات تقدير للمدارس المتفوّقة.</a:t>
-            </a:r>
-          </a:p>
-        </p:txBody>
-      </p:sp>
-      <p:sp>
-        <p:nvSpPr>
-          <p:cNvPr id="23" name="t23"/>
-          <p:cNvSpPr txBox="1"/>
-          <p:nvPr/>
-        </p:nvSpPr>
-        <p:spPr>
-          <a:xfrm>
-            <a:off x="944575" y="4892040"/>
-            <a:ext cx="5074920" cy="502920"/>
-          </a:xfrm>
-          <a:prstGeom prst="rect">
-            <a:avLst/>
-          </a:prstGeom>
-          <a:noFill/>
-        </p:spPr>
-        <p:txBody>
-          <a:bodyPr wrap="square" lIns="54864" tIns="36576" rIns="54864" bIns="36576" anchor="t" rtlCol="1">
-            <a:normAutofit/>
-          </a:bodyPr>
-          <a:lstStyle/>
-          <a:p>
-            <a:pPr marL="310896" indent="-310896" algn="r" rtl="1">
-              <a:buClr>
-                <a:srgbClr val="0F7A56"/>
-              </a:buClr>
-              <a:buFont typeface="Arial"/>
-              <a:buChar char="✓"/>
-            </a:pPr>
-            <a:r>
-              <a:rPr lang="ar-SA" sz="1400" dirty="0">
-                <a:solidFill>
-                  <a:srgbClr val="17281F"/>
-                </a:solidFill>
-                <a:latin typeface="Arial"/>
-                <a:cs typeface="Arial"/>
-              </a:rPr>
-              <a:t>تجهيزات وأدوات رياضية للمدرسة.</a:t>
-            </a:r>
-          </a:p>
-        </p:txBody>
-      </p:sp>
-      <p:sp>
-        <p:nvSpPr>
-          <p:cNvPr id="24" name="t24"/>
-          <p:cNvSpPr txBox="1"/>
-          <p:nvPr/>
-        </p:nvSpPr>
-        <p:spPr>
-          <a:xfrm>
-            <a:off x="6248095" y="5458968"/>
-            <a:ext cx="5074920" cy="502920"/>
-          </a:xfrm>
-          <a:prstGeom prst="rect">
-            <a:avLst/>
-          </a:prstGeom>
-          <a:noFill/>
-        </p:spPr>
-        <p:txBody>
-          <a:bodyPr wrap="square" lIns="54864" tIns="36576" rIns="54864" bIns="36576" anchor="t" rtlCol="1">
-            <a:normAutofit/>
-          </a:bodyPr>
-          <a:lstStyle/>
-          <a:p>
-            <a:pPr marL="310896" indent="-310896" algn="r" rtl="1">
-              <a:buClr>
-                <a:srgbClr val="0F7A56"/>
-              </a:buClr>
-              <a:buFont typeface="Arial"/>
-              <a:buChar char="✓"/>
-            </a:pPr>
-            <a:r>
-              <a:rPr lang="ar-SA" sz="1400" dirty="0">
-                <a:solidFill>
-                  <a:srgbClr val="17281F"/>
-                </a:solidFill>
-                <a:latin typeface="Arial"/>
-                <a:cs typeface="Arial"/>
-              </a:rPr>
-              <a:t>حوافز للطلاب والمعلمين المنسّقين.</a:t>
-            </a:r>
-          </a:p>
-        </p:txBody>
-      </p:sp>
-      <p:sp>
-        <p:nvSpPr>
-          <p:cNvPr id="25" name="t25"/>
-          <p:cNvSpPr txBox="1"/>
-          <p:nvPr/>
-        </p:nvSpPr>
-        <p:spPr>
-          <a:xfrm>
-            <a:off x="944575" y="5458968"/>
-            <a:ext cx="5074920" cy="502920"/>
-          </a:xfrm>
-          <a:prstGeom prst="rect">
-            <a:avLst/>
-          </a:prstGeom>
-          <a:noFill/>
-        </p:spPr>
-        <p:txBody>
-          <a:bodyPr wrap="square" lIns="54864" tIns="36576" rIns="54864" bIns="36576" anchor="t" rtlCol="1">
-            <a:normAutofit/>
-          </a:bodyPr>
-          <a:lstStyle/>
-          <a:p>
-            <a:pPr marL="310896" indent="-310896" algn="r" rtl="1">
-              <a:buClr>
-                <a:srgbClr val="0F7A56"/>
-              </a:buClr>
-              <a:buFont typeface="Arial"/>
-              <a:buChar char="✓"/>
-            </a:pPr>
-            <a:r>
-              <a:rPr lang="ar-SA" sz="1400" dirty="0">
-                <a:solidFill>
-                  <a:srgbClr val="17281F"/>
-                </a:solidFill>
-                <a:latin typeface="Arial"/>
-                <a:cs typeface="Arial"/>
-              </a:rPr>
-              <a:t>تكريم في فعالية ختامية للدوري.</a:t>
+              <a:rPr lang="ar-SA" sz="1250" dirty="0">
+                <a:solidFill>
+                  <a:srgbClr val="3E4C45"/>
+                </a:solidFill>
+                <a:latin typeface="Arial"/>
+                <a:cs typeface="Arial"/>
+              </a:rPr>
+              <a:t>لقاء وورشة مع مدرب المنتخب الوطني.</a:t>
+            </a:r>
+          </a:p>
+        </p:txBody>
+      </p:sp>
+      <p:sp>
+        <p:nvSpPr>
+          <p:cNvPr id="36" name="s36"/>
+          <p:cNvSpPr/>
+          <p:nvPr/>
+        </p:nvSpPr>
+        <p:spPr>
+          <a:xfrm>
+            <a:off x="640080" y="5806440"/>
+            <a:ext cx="10908792" cy="658368"/>
+          </a:xfrm>
+          <a:prstGeom prst="roundRect">
+            <a:avLst>
+              <a:gd name="adj" fmla="val 8000"/>
+            </a:avLst>
+          </a:prstGeom>
+          <a:solidFill>
+            <a:srgbClr val="0C3B2E"/>
+          </a:solidFill>
+        </p:spPr>
+        <p:txBody>
+          <a:bodyPr/>
+          <a:lstStyle/>
+          <a:p/>
+        </p:txBody>
+      </p:sp>
+      <p:sp>
+        <p:nvSpPr>
+          <p:cNvPr id="37" name="t37"/>
+          <p:cNvSpPr txBox="1"/>
+          <p:nvPr/>
+        </p:nvSpPr>
+        <p:spPr>
+          <a:xfrm>
+            <a:off x="868680" y="5806440"/>
+            <a:ext cx="10451592" cy="658368"/>
+          </a:xfrm>
+          <a:prstGeom prst="rect">
+            <a:avLst/>
+          </a:prstGeom>
+          <a:noFill/>
+        </p:spPr>
+        <p:txBody>
+          <a:bodyPr wrap="square" lIns="54864" tIns="18288" rIns="54864" bIns="18288" anchor="ctr" rtlCol="1">
+            <a:normAutofit/>
+          </a:bodyPr>
+          <a:lstStyle/>
+          <a:p>
+            <a:pPr algn="ctr" rtl="1"/>
+            <a:r>
+              <a:rPr lang="ar-SA" sz="1500" dirty="0">
+                <a:solidFill>
+                  <a:srgbClr val="FFFFFF"/>
+                </a:solidFill>
+                <a:latin typeface="Arial"/>
+                <a:cs typeface="Arial"/>
+              </a:rPr>
+              <a:t>وفي قمّة المحطات تنتظر المدرسة </a:t>
+            </a:r>
+            <a:r>
+              <a:rPr lang="ar-SA" sz="1500" b="1" dirty="0">
+                <a:solidFill>
+                  <a:srgbClr val="F4C542"/>
+                </a:solidFill>
+                <a:latin typeface="Arial"/>
+                <a:cs typeface="Arial"/>
+              </a:rPr>
+              <a:t>الجائزة الكبرى  ←</a:t>
             </a:r>
           </a:p>
         </p:txBody>
@@ -6617,7 +7444,7 @@
         </p:nvSpPr>
         <p:spPr>
           <a:xfrm>
-            <a:off x="-2377440" y="3291840"/>
+            <a:off x="-2560320" y="-2651760"/>
             <a:ext cx="5852160" cy="5852160"/>
           </a:xfrm>
           <a:prstGeom prst="ellipse">
@@ -6641,8 +7468,8 @@
         </p:nvSpPr>
         <p:spPr>
           <a:xfrm>
-            <a:off x="8595360" y="-2377440"/>
-            <a:ext cx="5852160" cy="5852160"/>
+            <a:off x="8961120" y="3017520"/>
+            <a:ext cx="6035040" cy="6035040"/>
           </a:xfrm>
           <a:prstGeom prst="ellipse">
             <a:avLst/>
@@ -6659,26 +7486,38 @@
       </p:sp>
       <p:sp>
         <p:nvSpPr>
-          <p:cNvPr id="5" name="s5"/>
-          <p:cNvSpPr/>
-          <p:nvPr/>
-        </p:nvSpPr>
-        <p:spPr>
-          <a:xfrm>
-            <a:off x="5458968" y="1051560"/>
-            <a:ext cx="1280160" cy="1280160"/>
-          </a:xfrm>
-          <a:prstGeom prst="ellipse">
-            <a:avLst/>
-          </a:prstGeom>
-          <a:solidFill>
-            <a:srgbClr val="E4A11B"/>
-          </a:solidFill>
-        </p:spPr>
-        <p:txBody>
-          <a:bodyPr/>
-          <a:lstStyle/>
-          <a:p/>
+          <p:cNvPr id="5" name="t5"/>
+          <p:cNvSpPr txBox="1"/>
+          <p:nvPr/>
+        </p:nvSpPr>
+        <p:spPr>
+          <a:xfrm>
+            <a:off x="914400" y="566928"/>
+            <a:ext cx="10360152" cy="411480"/>
+          </a:xfrm>
+          <a:prstGeom prst="rect">
+            <a:avLst/>
+          </a:prstGeom>
+          <a:noFill/>
+        </p:spPr>
+        <p:txBody>
+          <a:bodyPr wrap="square" lIns="54864" tIns="18288" rIns="54864" bIns="18288" anchor="t" rtlCol="1">
+            <a:normAutofit/>
+          </a:bodyPr>
+          <a:lstStyle/>
+          <a:p>
+            <a:pPr algn="ctr" rtl="1"/>
+            <a:r>
+              <a:rPr lang="ar-SA" sz="1600" b="1" dirty="0">
+                <a:solidFill>
+                  <a:srgbClr val="F4C542"/>
+                </a:solidFill>
+                <a:latin typeface="Arial"/>
+                <a:cs typeface="Arial"/>
+              </a:rPr>
+              <a:t>الجائزة الكبرى</a:t>
+            </a:r>
+          </a:p>
         </p:txBody>
       </p:sp>
       <p:sp>
@@ -6689,30 +7528,40 @@
         </p:nvSpPr>
         <p:spPr>
           <a:xfrm>
-            <a:off x="5458968" y="1051560"/>
-            <a:ext cx="1280160" cy="1280160"/>
-          </a:xfrm>
-          <a:prstGeom prst="rect">
-            <a:avLst/>
-          </a:prstGeom>
-          <a:noFill/>
-        </p:spPr>
-        <p:txBody>
-          <a:bodyPr wrap="square" lIns="0" tIns="0" rIns="0" bIns="0" anchor="ctr" rtlCol="1">
-            <a:normAutofit/>
-          </a:bodyPr>
-          <a:lstStyle/>
-          <a:p>
-            <a:pPr algn="ctr" rtl="0"/>
-            <a:r>
-              <a:rPr lang="ar-SA" sz="4400" b="1" dirty="0">
-                <a:solidFill>
-                  <a:srgbClr val="0C3B2E"/>
-                </a:solidFill>
-                <a:latin typeface="Arial"/>
-                <a:cs typeface="Arial"/>
-              </a:rPr>
-              <a:t>★</a:t>
+            <a:off x="914400" y="960120"/>
+            <a:ext cx="10360152" cy="868680"/>
+          </a:xfrm>
+          <a:prstGeom prst="rect">
+            <a:avLst/>
+          </a:prstGeom>
+          <a:noFill/>
+        </p:spPr>
+        <p:txBody>
+          <a:bodyPr wrap="square" lIns="54864" tIns="36576" rIns="54864" bIns="36576" anchor="t" rtlCol="1">
+            <a:normAutofit/>
+          </a:bodyPr>
+          <a:lstStyle/>
+          <a:p>
+            <a:pPr algn="ctr" rtl="1"/>
+            <a:r>
+              <a:rPr lang="ar-SA" sz="4800" b="1" dirty="0">
+                <a:solidFill>
+                  <a:srgbClr val="E4A11B"/>
+                </a:solidFill>
+                <a:latin typeface="Arial"/>
+                <a:cs typeface="Arial"/>
+              </a:rPr>
+              <a:t>1500</a:t>
+            </a:r>
+            <a:r>
+              <a:rPr lang="ar-SA" sz="2000" b="1" dirty="0">
+                <a:solidFill>
+                  <a:srgbClr val="FFFFFF"/>
+                </a:solidFill>
+                <a:latin typeface="Arial"/>
+                <a:cs typeface="Arial"/>
+              </a:rPr>
+              <a:t>  نقطة</a:t>
             </a:r>
           </a:p>
         </p:txBody>
@@ -6725,8 +7574,8 @@
         </p:nvSpPr>
         <p:spPr>
           <a:xfrm>
-            <a:off x="914400" y="2606040"/>
-            <a:ext cx="10360152" cy="914400"/>
+            <a:off x="914400" y="1874520"/>
+            <a:ext cx="10360152" cy="502920"/>
           </a:xfrm>
           <a:prstGeom prst="rect">
             <a:avLst/>
@@ -6741,14 +7590,14 @@
           <a:p>
             <a:pPr algn="ctr" rtl="1"/>
             <a:r>
-              <a:rPr lang="ar-SA" sz="3000" b="1" dirty="0">
+              <a:rPr lang="ar-SA" sz="2600" b="1" dirty="0">
                 <a:solidFill>
                   <a:srgbClr val="FFFFFF"/>
                 </a:solidFill>
                 <a:latin typeface="Arial"/>
                 <a:cs typeface="Arial"/>
               </a:rPr>
-              <a:t>حركة أكثر، ومنافسة أمتع، وأثر مستدام</a:t>
+              <a:t>تكريم على أعلى مستوى</a:t>
             </a:r>
           </a:p>
         </p:txBody>
@@ -6761,8 +7610,8 @@
         </p:nvSpPr>
         <p:spPr>
           <a:xfrm>
-            <a:off x="1371600" y="3611880"/>
-            <a:ext cx="9445752" cy="822960"/>
+            <a:off x="914400" y="2414016"/>
+            <a:ext cx="10360152" cy="365760"/>
           </a:xfrm>
           <a:prstGeom prst="rect">
             <a:avLst/>
@@ -6777,14 +7626,14 @@
           <a:p>
             <a:pPr algn="ctr" rtl="1"/>
             <a:r>
-              <a:rPr lang="ar-SA" sz="1600" dirty="0">
+              <a:rPr lang="ar-SA" sz="1400" dirty="0">
                 <a:solidFill>
                   <a:srgbClr val="BFE3D0"/>
                 </a:solidFill>
                 <a:latin typeface="Arial"/>
                 <a:cs typeface="Arial"/>
               </a:rPr>
-              <a:t>نظام تحفيز بسيط وعادل وقابل للقياس — يركّز النقاط على ما يصنع الفرق: المباريات والحصص التدريبية.</a:t>
+              <a:t>تُمنح للمدرسة التي تبلغ رصيد 1500 نقطة</a:t>
             </a:r>
           </a:p>
         </p:txBody>
@@ -6797,162 +7646,368 @@
         </p:nvSpPr>
         <p:spPr>
           <a:xfrm>
-            <a:off x="3794760" y="4709160"/>
-            <a:ext cx="2103120" cy="1234440"/>
+            <a:off x="6278728" y="2926080"/>
+            <a:ext cx="4846320" cy="2880360"/>
           </a:xfrm>
           <a:prstGeom prst="roundRect">
             <a:avLst>
-              <a:gd name="adj" fmla="val 10000"/>
+              <a:gd name="adj" fmla="val 5000"/>
             </a:avLst>
           </a:prstGeom>
           <a:solidFill>
-            <a:srgbClr val="0A3227"/>
-          </a:solidFill>
-          <a:ln w="15875">
-            <a:solidFill>
-              <a:srgbClr val="E4A11B"/>
-            </a:solidFill>
-          </a:ln>
-        </p:spPr>
-        <p:txBody>
-          <a:bodyPr/>
-          <a:lstStyle/>
-          <a:p/>
-        </p:txBody>
-      </p:sp>
-      <p:sp>
-        <p:nvSpPr>
-          <p:cNvPr id="10" name="t10"/>
-          <p:cNvSpPr txBox="1"/>
-          <p:nvPr/>
-        </p:nvSpPr>
-        <p:spPr>
-          <a:xfrm>
-            <a:off x="3794760" y="4800600"/>
-            <a:ext cx="2103120" cy="1097280"/>
-          </a:xfrm>
-          <a:prstGeom prst="rect">
-            <a:avLst/>
-          </a:prstGeom>
-          <a:noFill/>
-        </p:spPr>
-        <p:txBody>
-          <a:bodyPr wrap="square" lIns="54864" tIns="36576" rIns="54864" bIns="36576" anchor="ctr" rtlCol="1">
-            <a:normAutofit/>
-          </a:bodyPr>
-          <a:lstStyle/>
-          <a:p>
-            <a:pPr algn="ctr" rtl="0">
-              <a:spcAft>
-                <a:spcPts val="200"/>
-              </a:spcAft>
+            <a:srgbClr val="FFFFFF"/>
+          </a:solidFill>
+          <a:effectLst>
+            <a:outerShdw blurRad="90000" dist="38100" dir="5400000" rotWithShape="0">
+              <a:srgbClr val="0C3B2E">
+                <a:alpha val="20000"/>
+              </a:srgbClr>
+            </a:outerShdw>
+          </a:effectLst>
+        </p:spPr>
+        <p:txBody>
+          <a:bodyPr/>
+          <a:lstStyle/>
+          <a:p/>
+        </p:txBody>
+      </p:sp>
+      <p:sp>
+        <p:nvSpPr>
+          <p:cNvPr id="10" name="s10"/>
+          <p:cNvSpPr/>
+          <p:nvPr/>
+        </p:nvSpPr>
+        <p:spPr>
+          <a:xfrm>
+            <a:off x="8244688" y="3291840"/>
+            <a:ext cx="914400" cy="914400"/>
+          </a:xfrm>
+          <a:prstGeom prst="ellipse">
+            <a:avLst/>
+          </a:prstGeom>
+          <a:solidFill>
+            <a:srgbClr val="E4A11B"/>
+          </a:solidFill>
+        </p:spPr>
+        <p:txBody>
+          <a:bodyPr/>
+          <a:lstStyle/>
+          <a:p/>
+        </p:txBody>
+      </p:sp>
+      <p:sp>
+        <p:nvSpPr>
+          <p:cNvPr id="11" name="t11"/>
+          <p:cNvSpPr txBox="1"/>
+          <p:nvPr/>
+        </p:nvSpPr>
+        <p:spPr>
+          <a:xfrm>
+            <a:off x="8244688" y="3291840"/>
+            <a:ext cx="914400" cy="914400"/>
+          </a:xfrm>
+          <a:prstGeom prst="rect">
+            <a:avLst/>
+          </a:prstGeom>
+          <a:noFill/>
+        </p:spPr>
+        <p:txBody>
+          <a:bodyPr wrap="square" lIns="0" tIns="0" rIns="0" bIns="0" anchor="ctr" rtlCol="1">
+            <a:normAutofit/>
+          </a:bodyPr>
+          <a:lstStyle/>
+          <a:p>
+            <a:pPr algn="ctr" rtl="0"/>
+            <a:r>
+              <a:rPr lang="ar-SA" sz="3400" b="1" dirty="0">
+                <a:solidFill>
+                  <a:srgbClr val="0C3B2E"/>
+                </a:solidFill>
+                <a:latin typeface="Arial"/>
+                <a:cs typeface="Arial"/>
+              </a:rPr>
+              <a:t>★</a:t>
+            </a:r>
+          </a:p>
+        </p:txBody>
+      </p:sp>
+      <p:sp>
+        <p:nvSpPr>
+          <p:cNvPr id="12" name="t12"/>
+          <p:cNvSpPr txBox="1"/>
+          <p:nvPr/>
+        </p:nvSpPr>
+        <p:spPr>
+          <a:xfrm>
+            <a:off x="6553048" y="4407408"/>
+            <a:ext cx="4297680" cy="502920"/>
+          </a:xfrm>
+          <a:prstGeom prst="rect">
+            <a:avLst/>
+          </a:prstGeom>
+          <a:noFill/>
+        </p:spPr>
+        <p:txBody>
+          <a:bodyPr wrap="square" lIns="54864" tIns="18288" rIns="54864" bIns="18288" anchor="t" rtlCol="1">
+            <a:normAutofit/>
+          </a:bodyPr>
+          <a:lstStyle/>
+          <a:p>
+            <a:pPr algn="ctr" rtl="1"/>
+            <a:r>
+              <a:rPr lang="ar-SA" sz="2000" b="1" dirty="0">
+                <a:solidFill>
+                  <a:srgbClr val="17281F"/>
+                </a:solidFill>
+                <a:latin typeface="Arial"/>
+                <a:cs typeface="Arial"/>
+              </a:rPr>
+              <a:t>خطاب شكر وتقدير رسمي</a:t>
+            </a:r>
+          </a:p>
+        </p:txBody>
+      </p:sp>
+      <p:sp>
+        <p:nvSpPr>
+          <p:cNvPr id="13" name="t13"/>
+          <p:cNvSpPr txBox="1"/>
+          <p:nvPr/>
+        </p:nvSpPr>
+        <p:spPr>
+          <a:xfrm>
+            <a:off x="6735928" y="4956048"/>
+            <a:ext cx="3931920" cy="731520"/>
+          </a:xfrm>
+          <a:prstGeom prst="rect">
+            <a:avLst/>
+          </a:prstGeom>
+          <a:noFill/>
+        </p:spPr>
+        <p:txBody>
+          <a:bodyPr wrap="square" lIns="54864" tIns="36576" rIns="54864" bIns="36576" anchor="t" rtlCol="1">
+            <a:normAutofit/>
+          </a:bodyPr>
+          <a:lstStyle/>
+          <a:p>
+            <a:pPr algn="ctr" rtl="1">
+              <a:lnSpc>
+                <a:spcPct val="135000"/>
+              </a:lnSpc>
             </a:pPr>
             <a:r>
-              <a:rPr lang="ar-SA" sz="4000" b="1" dirty="0">
-                <a:solidFill>
-                  <a:srgbClr val="F4C542"/>
-                </a:solidFill>
-                <a:latin typeface="Arial"/>
-                <a:cs typeface="Arial"/>
-              </a:rPr>
-              <a:t>10</a:t>
-            </a:r>
-          </a:p>
-          <a:p>
-            <a:pPr algn="ctr" rtl="1"/>
-            <a:r>
-              <a:rPr lang="ar-SA" sz="1200" dirty="0">
-                <a:solidFill>
-                  <a:srgbClr val="FFFFFF"/>
-                </a:solidFill>
-                <a:latin typeface="Arial"/>
-                <a:cs typeface="Arial"/>
-              </a:rPr>
-              <a:t>نقاط / مباراة</a:t>
-            </a:r>
-          </a:p>
-        </p:txBody>
-      </p:sp>
-      <p:sp>
-        <p:nvSpPr>
-          <p:cNvPr id="11" name="s11"/>
-          <p:cNvSpPr/>
-          <p:nvPr/>
-        </p:nvSpPr>
-        <p:spPr>
-          <a:xfrm>
-            <a:off x="6291072" y="4709160"/>
-            <a:ext cx="2103120" cy="1234440"/>
+              <a:rPr lang="ar-SA" sz="1450" dirty="0">
+                <a:solidFill>
+                  <a:srgbClr val="3E4C45"/>
+                </a:solidFill>
+                <a:latin typeface="Arial"/>
+                <a:cs typeface="Arial"/>
+              </a:rPr>
+              <a:t>من وزير التعليم ووزير الرياضة — باسم المدرسة ومعلم الرياضة.</a:t>
+            </a:r>
+          </a:p>
+        </p:txBody>
+      </p:sp>
+      <p:sp>
+        <p:nvSpPr>
+          <p:cNvPr id="14" name="s14"/>
+          <p:cNvSpPr/>
+          <p:nvPr/>
+        </p:nvSpPr>
+        <p:spPr>
+          <a:xfrm>
+            <a:off x="1066648" y="2926080"/>
+            <a:ext cx="4846320" cy="2880360"/>
           </a:xfrm>
           <a:prstGeom prst="roundRect">
             <a:avLst>
-              <a:gd name="adj" fmla="val 10000"/>
+              <a:gd name="adj" fmla="val 5000"/>
             </a:avLst>
           </a:prstGeom>
           <a:solidFill>
-            <a:srgbClr val="0A3227"/>
-          </a:solidFill>
-          <a:ln w="15875">
-            <a:solidFill>
-              <a:srgbClr val="E4A11B"/>
-            </a:solidFill>
-          </a:ln>
-        </p:spPr>
-        <p:txBody>
-          <a:bodyPr/>
-          <a:lstStyle/>
-          <a:p/>
-        </p:txBody>
-      </p:sp>
-      <p:sp>
-        <p:nvSpPr>
-          <p:cNvPr id="12" name="t12"/>
-          <p:cNvSpPr txBox="1"/>
-          <p:nvPr/>
-        </p:nvSpPr>
-        <p:spPr>
-          <a:xfrm>
-            <a:off x="6291072" y="4800600"/>
-            <a:ext cx="2103120" cy="1097280"/>
-          </a:xfrm>
-          <a:prstGeom prst="rect">
-            <a:avLst/>
-          </a:prstGeom>
-          <a:noFill/>
-        </p:spPr>
-        <p:txBody>
-          <a:bodyPr wrap="square" lIns="54864" tIns="36576" rIns="54864" bIns="36576" anchor="ctr" rtlCol="1">
-            <a:normAutofit/>
-          </a:bodyPr>
-          <a:lstStyle/>
-          <a:p>
-            <a:pPr algn="ctr" rtl="0">
-              <a:spcAft>
-                <a:spcPts val="200"/>
-              </a:spcAft>
+            <a:srgbClr val="FFFFFF"/>
+          </a:solidFill>
+          <a:effectLst>
+            <a:outerShdw blurRad="90000" dist="38100" dir="5400000" rotWithShape="0">
+              <a:srgbClr val="0C3B2E">
+                <a:alpha val="20000"/>
+              </a:srgbClr>
+            </a:outerShdw>
+          </a:effectLst>
+        </p:spPr>
+        <p:txBody>
+          <a:bodyPr/>
+          <a:lstStyle/>
+          <a:p/>
+        </p:txBody>
+      </p:sp>
+      <p:sp>
+        <p:nvSpPr>
+          <p:cNvPr id="15" name="s15"/>
+          <p:cNvSpPr/>
+          <p:nvPr/>
+        </p:nvSpPr>
+        <p:spPr>
+          <a:xfrm>
+            <a:off x="3032608" y="3291840"/>
+            <a:ext cx="914400" cy="914400"/>
+          </a:xfrm>
+          <a:prstGeom prst="ellipse">
+            <a:avLst/>
+          </a:prstGeom>
+          <a:solidFill>
+            <a:srgbClr val="E4A11B"/>
+          </a:solidFill>
+        </p:spPr>
+        <p:txBody>
+          <a:bodyPr/>
+          <a:lstStyle/>
+          <a:p/>
+        </p:txBody>
+      </p:sp>
+      <p:sp>
+        <p:nvSpPr>
+          <p:cNvPr id="16" name="t16"/>
+          <p:cNvSpPr txBox="1"/>
+          <p:nvPr/>
+        </p:nvSpPr>
+        <p:spPr>
+          <a:xfrm>
+            <a:off x="3032608" y="3291840"/>
+            <a:ext cx="914400" cy="914400"/>
+          </a:xfrm>
+          <a:prstGeom prst="rect">
+            <a:avLst/>
+          </a:prstGeom>
+          <a:noFill/>
+        </p:spPr>
+        <p:txBody>
+          <a:bodyPr wrap="square" lIns="0" tIns="0" rIns="0" bIns="0" anchor="ctr" rtlCol="1">
+            <a:normAutofit/>
+          </a:bodyPr>
+          <a:lstStyle/>
+          <a:p>
+            <a:pPr algn="ctr" rtl="0"/>
+            <a:r>
+              <a:rPr lang="ar-SA" sz="3400" b="1" dirty="0">
+                <a:solidFill>
+                  <a:srgbClr val="0C3B2E"/>
+                </a:solidFill>
+                <a:latin typeface="Arial"/>
+                <a:cs typeface="Arial"/>
+              </a:rPr>
+              <a:t>◆</a:t>
+            </a:r>
+          </a:p>
+        </p:txBody>
+      </p:sp>
+      <p:sp>
+        <p:nvSpPr>
+          <p:cNvPr id="17" name="t17"/>
+          <p:cNvSpPr txBox="1"/>
+          <p:nvPr/>
+        </p:nvSpPr>
+        <p:spPr>
+          <a:xfrm>
+            <a:off x="1340968" y="4407408"/>
+            <a:ext cx="4297680" cy="502920"/>
+          </a:xfrm>
+          <a:prstGeom prst="rect">
+            <a:avLst/>
+          </a:prstGeom>
+          <a:noFill/>
+        </p:spPr>
+        <p:txBody>
+          <a:bodyPr wrap="square" lIns="54864" tIns="18288" rIns="54864" bIns="18288" anchor="t" rtlCol="1">
+            <a:normAutofit/>
+          </a:bodyPr>
+          <a:lstStyle/>
+          <a:p>
+            <a:pPr algn="ctr" rtl="1"/>
+            <a:r>
+              <a:rPr lang="ar-SA" sz="2000" b="1" dirty="0">
+                <a:solidFill>
+                  <a:srgbClr val="17281F"/>
+                </a:solidFill>
+                <a:latin typeface="Arial"/>
+                <a:cs typeface="Arial"/>
+              </a:rPr>
+              <a:t>دعم رخصة التدريب</a:t>
+            </a:r>
+          </a:p>
+        </p:txBody>
+      </p:sp>
+      <p:sp>
+        <p:nvSpPr>
+          <p:cNvPr id="18" name="t18"/>
+          <p:cNvSpPr txBox="1"/>
+          <p:nvPr/>
+        </p:nvSpPr>
+        <p:spPr>
+          <a:xfrm>
+            <a:off x="1523848" y="4956048"/>
+            <a:ext cx="3931920" cy="731520"/>
+          </a:xfrm>
+          <a:prstGeom prst="rect">
+            <a:avLst/>
+          </a:prstGeom>
+          <a:noFill/>
+        </p:spPr>
+        <p:txBody>
+          <a:bodyPr wrap="square" lIns="54864" tIns="36576" rIns="54864" bIns="36576" anchor="t" rtlCol="1">
+            <a:normAutofit/>
+          </a:bodyPr>
+          <a:lstStyle/>
+          <a:p>
+            <a:pPr algn="ctr" rtl="1">
+              <a:lnSpc>
+                <a:spcPct val="135000"/>
+              </a:lnSpc>
             </a:pPr>
             <a:r>
-              <a:rPr lang="ar-SA" sz="4000" b="1" dirty="0">
-                <a:solidFill>
-                  <a:srgbClr val="F4C542"/>
-                </a:solidFill>
-                <a:latin typeface="Arial"/>
-                <a:cs typeface="Arial"/>
-              </a:rPr>
-              <a:t>15</a:t>
-            </a:r>
-          </a:p>
+              <a:rPr lang="ar-SA" sz="1450" dirty="0">
+                <a:solidFill>
+                  <a:srgbClr val="3E4C45"/>
+                </a:solidFill>
+                <a:latin typeface="Arial"/>
+                <a:cs typeface="Arial"/>
+              </a:rPr>
+              <a:t>الحصول على رخصة تدريب رياضي مجانًا وبدون رسوم لمعلم الرياضة.</a:t>
+            </a:r>
+          </a:p>
+        </p:txBody>
+      </p:sp>
+      <p:sp>
+        <p:nvSpPr>
+          <p:cNvPr id="19" name="t19"/>
+          <p:cNvSpPr txBox="1"/>
+          <p:nvPr/>
+        </p:nvSpPr>
+        <p:spPr>
+          <a:xfrm>
+            <a:off x="914400" y="6053328"/>
+            <a:ext cx="10360152" cy="411480"/>
+          </a:xfrm>
+          <a:prstGeom prst="rect">
+            <a:avLst/>
+          </a:prstGeom>
+          <a:noFill/>
+        </p:spPr>
+        <p:txBody>
+          <a:bodyPr wrap="square" lIns="54864" tIns="18288" rIns="54864" bIns="18288" anchor="t" rtlCol="1">
+            <a:normAutofit/>
+          </a:bodyPr>
+          <a:lstStyle/>
           <a:p>
             <a:pPr algn="ctr" rtl="1"/>
             <a:r>
-              <a:rPr lang="ar-SA" sz="1200" dirty="0">
-                <a:solidFill>
-                  <a:srgbClr val="FFFFFF"/>
-                </a:solidFill>
-                <a:latin typeface="Arial"/>
-                <a:cs typeface="Arial"/>
-              </a:rPr>
-              <a:t>نقطة / حصة</a:t>
+              <a:rPr lang="ar-SA" sz="1350" i="1" dirty="0">
+                <a:solidFill>
+                  <a:srgbClr val="BFE3D0"/>
+                </a:solidFill>
+                <a:latin typeface="Arial"/>
+                <a:cs typeface="Arial"/>
+              </a:rPr>
+              <a:t>تكريم رمزي ومهني يُتوّج رحلة المدرسة في الدوري.</a:t>
             </a:r>
           </a:p>
         </p:txBody>

</xml_diff>